<commit_message>
Add visible sources to Round 1 pitch
</commit_message>
<xml_diff>
--- a/presentation/round1_pitch.pptx
+++ b/presentation/round1_pitch.pptx
@@ -2,26 +2,26 @@
 <file path=ppt/presentation.xml><?xml version="1.0" encoding="utf-8"?>
 <p:presentation xmlns:p="http://schemas.openxmlformats.org/presentationml/2006/main">
   <p:sldMasterIdLst>
-    <p:sldMasterId xmlns:r="http://schemas.openxmlformats.org/officeDocument/2006/relationships" id="2147483648" r:id="R7a76bfd0bcea46e7"/>
+    <p:sldMasterId xmlns:r="http://schemas.openxmlformats.org/officeDocument/2006/relationships" id="2147483648" r:id="R73b9547b469547b3"/>
   </p:sldMasterIdLst>
   <p:notesMasterIdLst>
-    <p:notesMasterId xmlns:r="http://schemas.openxmlformats.org/officeDocument/2006/relationships" r:id="Rd73e6dfdb0d84c88"/>
+    <p:notesMasterId xmlns:r="http://schemas.openxmlformats.org/officeDocument/2006/relationships" r:id="R56410e7f2b5445be"/>
   </p:notesMasterIdLst>
   <p:sldIdLst>
-    <p:sldId xmlns:r="http://schemas.openxmlformats.org/officeDocument/2006/relationships" id="256" r:id="R883a0ea1f87f416d"/>
-    <p:sldId xmlns:r="http://schemas.openxmlformats.org/officeDocument/2006/relationships" id="257" r:id="Rb55d5a90365f436f"/>
-    <p:sldId xmlns:r="http://schemas.openxmlformats.org/officeDocument/2006/relationships" id="258" r:id="R1f725f9b78f24821"/>
-    <p:sldId xmlns:r="http://schemas.openxmlformats.org/officeDocument/2006/relationships" id="259" r:id="R06706de16095453b"/>
-    <p:sldId xmlns:r="http://schemas.openxmlformats.org/officeDocument/2006/relationships" id="260" r:id="R14347f17fb71450f"/>
-    <p:sldId xmlns:r="http://schemas.openxmlformats.org/officeDocument/2006/relationships" id="261" r:id="R0be6c43eccec450a"/>
-    <p:sldId xmlns:r="http://schemas.openxmlformats.org/officeDocument/2006/relationships" id="262" r:id="R76707a4419354669"/>
-    <p:sldId xmlns:r="http://schemas.openxmlformats.org/officeDocument/2006/relationships" id="263" r:id="R356748d9a6ed48ab"/>
-    <p:sldId xmlns:r="http://schemas.openxmlformats.org/officeDocument/2006/relationships" id="264" r:id="R3ab75f0f4b3f4b0c"/>
-    <p:sldId xmlns:r="http://schemas.openxmlformats.org/officeDocument/2006/relationships" id="265" r:id="R40d8dc9b2fd54897"/>
-    <p:sldId xmlns:r="http://schemas.openxmlformats.org/officeDocument/2006/relationships" id="266" r:id="R1e277a1a106642de"/>
-    <p:sldId xmlns:r="http://schemas.openxmlformats.org/officeDocument/2006/relationships" id="267" r:id="R7b0132ac71e74b48"/>
-    <p:sldId xmlns:r="http://schemas.openxmlformats.org/officeDocument/2006/relationships" id="268" r:id="R0fbe23acbb8144d5"/>
-    <p:sldId xmlns:r="http://schemas.openxmlformats.org/officeDocument/2006/relationships" id="269" r:id="R26e6a4bb631f410c"/>
+    <p:sldId xmlns:r="http://schemas.openxmlformats.org/officeDocument/2006/relationships" id="256" r:id="Rd26def38410049a6"/>
+    <p:sldId xmlns:r="http://schemas.openxmlformats.org/officeDocument/2006/relationships" id="257" r:id="R3b22b0014225498d"/>
+    <p:sldId xmlns:r="http://schemas.openxmlformats.org/officeDocument/2006/relationships" id="258" r:id="R2380e23fe235466c"/>
+    <p:sldId xmlns:r="http://schemas.openxmlformats.org/officeDocument/2006/relationships" id="259" r:id="R71735fc5ac9245f7"/>
+    <p:sldId xmlns:r="http://schemas.openxmlformats.org/officeDocument/2006/relationships" id="260" r:id="R4465b0b26c30493c"/>
+    <p:sldId xmlns:r="http://schemas.openxmlformats.org/officeDocument/2006/relationships" id="261" r:id="Ree76443202e54b62"/>
+    <p:sldId xmlns:r="http://schemas.openxmlformats.org/officeDocument/2006/relationships" id="262" r:id="Re572e4008d7043db"/>
+    <p:sldId xmlns:r="http://schemas.openxmlformats.org/officeDocument/2006/relationships" id="263" r:id="R91b3ac2167354724"/>
+    <p:sldId xmlns:r="http://schemas.openxmlformats.org/officeDocument/2006/relationships" id="264" r:id="R2f801f5078704be1"/>
+    <p:sldId xmlns:r="http://schemas.openxmlformats.org/officeDocument/2006/relationships" id="265" r:id="Reba12b63adad48d7"/>
+    <p:sldId xmlns:r="http://schemas.openxmlformats.org/officeDocument/2006/relationships" id="266" r:id="R752d83818c864954"/>
+    <p:sldId xmlns:r="http://schemas.openxmlformats.org/officeDocument/2006/relationships" id="267" r:id="R05b391fee938463e"/>
+    <p:sldId xmlns:r="http://schemas.openxmlformats.org/officeDocument/2006/relationships" id="268" r:id="R794c731530f349d4"/>
+    <p:sldId xmlns:r="http://schemas.openxmlformats.org/officeDocument/2006/relationships" id="269" r:id="R97516b331451472e"/>
   </p:sldIdLst>
   <p:sldSz cx="12192000" cy="6858000"/>
   <p:notesSz cx="6858000" cy="9144000"/>
@@ -515,7 +515,7 @@
           </a:p>
           <a:p xmlns:a="http://schemas.openxmlformats.org/drawingml/2006/main">
             <a:r>
-              <a:t>The workflow runs, its reasoning is visible, and every number traces to project evidence.</a:t>
+              <a:t>The workflow runs, its reasoning is visible, and every number traces to project evidence, including public complaint data from the U.S. Consumer Financial Protection Bureau, or CFPB.</a:t>
             </a:r>
           </a:p>
           <a:p xmlns:a="http://schemas.openxmlformats.org/drawingml/2006/main">
@@ -536,6 +536,11 @@
           <a:p xmlns:a="http://schemas.openxmlformats.org/drawingml/2006/main">
             <a:r>
               <a:t>[Sources]</a:t>
+            </a:r>
+          </a:p>
+          <a:p xmlns:a="http://schemas.openxmlformats.org/drawingml/2006/main">
+            <a:r>
+              <a:t>- CFPB Consumer Complaint Database: https://www.consumerfinance.gov/data-research/consumer-complaints/</a:t>
             </a:r>
           </a:p>
           <a:p xmlns:a="http://schemas.openxmlformats.org/drawingml/2006/main">
@@ -2303,7 +2308,7 @@
   </p:cSld>
   <p:clrMap bg1="lt1" tx1="dk1" bg2="lt2" tx2="dk2" accent1="accent1" accent2="accent2" accent3="accent3" accent4="accent4" accent5="accent5" accent6="accent6" hlink="hlink" folHlink="folHlink"/>
   <p:sldLayoutIdLst>
-    <p:sldLayoutId xmlns:r="http://schemas.openxmlformats.org/officeDocument/2006/relationships" id="2147483649" r:id="R611ed53a67cf4025"/>
+    <p:sldLayoutId xmlns:r="http://schemas.openxmlformats.org/officeDocument/2006/relationships" id="2147483649" r:id="Rfe782b5d4bde487d"/>
   </p:sldLayoutIdLst>
   <p:hf sldNum="0" hdr="0" ftr="0" dt="0"/>
   <p:txStyles>
@@ -3200,7 +3205,18 @@
                 <a:ea typeface="Calibri"/>
                 <a:cs typeface="Calibri"/>
               </a:rPr>
-              <a:t>Public CFPB data · 16,839 complaints    </a:t>
+              <a:t>U.S. Consumer Financial Protection Bureau (CFPB) · public complaint data</a:t>
+            </a:r>
+            <a:r>
+              <a:rPr sz="900">
+                <a:solidFill>
+                  <a:srgbClr val="6B7C88"/>
+                </a:solidFill>
+                <a:latin typeface="Calibri"/>
+                <a:ea typeface="Calibri"/>
+                <a:cs typeface="Calibri"/>
+              </a:rPr>
+              <a:t>    </a:t>
             </a:r>
             <a:r>
               <a:rPr sz="900">
@@ -3420,7 +3436,7 @@
           <p:nvPr/>
         </p:nvPicPr>
         <p:blipFill>
-          <a:blip xmlns:r="http://schemas.openxmlformats.org/officeDocument/2006/relationships" xmlns:a="http://schemas.openxmlformats.org/drawingml/2006/main" r:embed="R904af97ae8654a15"/>
+          <a:blip xmlns:r="http://schemas.openxmlformats.org/officeDocument/2006/relationships" xmlns:a="http://schemas.openxmlformats.org/drawingml/2006/main" r:embed="R0e4194775f0846d6"/>
           <a:stretch xmlns:a="http://schemas.openxmlformats.org/drawingml/2006/main">
             <a:fillRect l="0" t="0" r="0" b="0"/>
           </a:stretch>
@@ -3651,9 +3667,22 @@
           <a:bodyPr xmlns:a="http://schemas.openxmlformats.org/drawingml/2006/main" wrap="square" lIns="0" tIns="0" rIns="0" bIns="0" anchor="ctr"/>
           <a:lstStyle xmlns:a="http://schemas.openxmlformats.org/drawingml/2006/main"/>
           <a:p xmlns:a="http://schemas.openxmlformats.org/drawingml/2006/main">
-            <a:pPr marL="0" indent="0">
+            <a:pPr marL="0" indent="0" algn="l">
               <a:buNone/>
+              <a:defRPr sz="900" b="0">
+                <a:solidFill>
+                  <a:srgbClr val="6B7C88"/>
+                </a:solidFill>
+              </a:defRPr>
             </a:pPr>
+            <a:r>
+              <a:rPr sz="900" b="0">
+                <a:solidFill>
+                  <a:srgbClr val="6B7C88"/>
+                </a:solidFill>
+              </a:rPr>
+              <a:t>Source: Project LangSmith evaluation (n=60 public CFPB complaints).</a:t>
+            </a:r>
             <a:endParaRPr sz="850"/>
           </a:p>
         </p:txBody>
@@ -4437,7 +4466,7 @@
           <p:nvPr/>
         </p:nvPicPr>
         <p:blipFill>
-          <a:blip xmlns:r="http://schemas.openxmlformats.org/officeDocument/2006/relationships" xmlns:a="http://schemas.openxmlformats.org/drawingml/2006/main" r:embed="Raf04b2489948485a"/>
+          <a:blip xmlns:r="http://schemas.openxmlformats.org/officeDocument/2006/relationships" xmlns:a="http://schemas.openxmlformats.org/drawingml/2006/main" r:embed="Rf3668b642f14462f"/>
           <a:stretch xmlns:a="http://schemas.openxmlformats.org/drawingml/2006/main">
             <a:fillRect l="0" t="0" r="0" b="0"/>
           </a:stretch>
@@ -4657,9 +4686,22 @@
           <a:bodyPr xmlns:a="http://schemas.openxmlformats.org/drawingml/2006/main" wrap="square" lIns="0" tIns="0" rIns="0" bIns="0" anchor="ctr"/>
           <a:lstStyle xmlns:a="http://schemas.openxmlformats.org/drawingml/2006/main"/>
           <a:p xmlns:a="http://schemas.openxmlformats.org/drawingml/2006/main">
-            <a:pPr marL="0" indent="0">
+            <a:pPr marL="0" indent="0" algn="l">
               <a:buNone/>
+              <a:defRPr sz="900" b="0">
+                <a:solidFill>
+                  <a:srgbClr val="6B7C88"/>
+                </a:solidFill>
+              </a:defRPr>
             </a:pPr>
+            <a:r>
+              <a:rPr sz="900" b="0">
+                <a:solidFill>
+                  <a:srgbClr val="6B7C88"/>
+                </a:solidFill>
+              </a:rPr>
+              <a:t>Source: Project evaluation vs CFPB-derived labels (gpt-4o, n=240); agreement, not accuracy.</a:t>
+            </a:r>
             <a:endParaRPr sz="850"/>
           </a:p>
         </p:txBody>
@@ -5231,7 +5273,7 @@
           <p:nvPr/>
         </p:nvPicPr>
         <p:blipFill>
-          <a:blip xmlns:r="http://schemas.openxmlformats.org/officeDocument/2006/relationships" xmlns:a="http://schemas.openxmlformats.org/drawingml/2006/main" r:embed="R4584125345324127"/>
+          <a:blip xmlns:r="http://schemas.openxmlformats.org/officeDocument/2006/relationships" xmlns:a="http://schemas.openxmlformats.org/drawingml/2006/main" r:embed="R101fb8bc4b45479f"/>
           <a:stretch xmlns:a="http://schemas.openxmlformats.org/drawingml/2006/main">
             <a:fillRect l="0" t="0" r="0" b="0"/>
           </a:stretch>
@@ -5462,9 +5504,22 @@
           <a:bodyPr xmlns:a="http://schemas.openxmlformats.org/drawingml/2006/main" wrap="square" lIns="0" tIns="0" rIns="0" bIns="0" anchor="ctr"/>
           <a:lstStyle xmlns:a="http://schemas.openxmlformats.org/drawingml/2006/main"/>
           <a:p xmlns:a="http://schemas.openxmlformats.org/drawingml/2006/main">
-            <a:pPr marL="0" indent="0">
+            <a:pPr marL="0" indent="0" algn="l">
               <a:buNone/>
+              <a:defRPr sz="900" b="0">
+                <a:solidFill>
+                  <a:srgbClr val="6B7C88"/>
+                </a:solidFill>
+              </a:defRPr>
             </a:pPr>
+            <a:r>
+              <a:rPr sz="900" b="0">
+                <a:solidFill>
+                  <a:srgbClr val="6B7C88"/>
+                </a:solidFill>
+              </a:rPr>
+              <a:t>Source: CFPB data-quality review; analysis window ends 27 Jun 2026.</a:t>
+            </a:r>
             <a:endParaRPr sz="850"/>
           </a:p>
         </p:txBody>
@@ -6048,7 +6103,7 @@
           <p:nvPr/>
         </p:nvPicPr>
         <p:blipFill>
-          <a:blip xmlns:r="http://schemas.openxmlformats.org/officeDocument/2006/relationships" xmlns:a="http://schemas.openxmlformats.org/drawingml/2006/main" r:embed="R3b26cb9bdd7f4a2b"/>
+          <a:blip xmlns:r="http://schemas.openxmlformats.org/officeDocument/2006/relationships" xmlns:a="http://schemas.openxmlformats.org/drawingml/2006/main" r:embed="R755aed03094c477a"/>
           <a:stretch xmlns:a="http://schemas.openxmlformats.org/drawingml/2006/main">
             <a:fillRect l="0" t="0" r="0" b="0"/>
           </a:stretch>
@@ -6268,9 +6323,22 @@
           <a:bodyPr xmlns:a="http://schemas.openxmlformats.org/drawingml/2006/main" wrap="square" lIns="0" tIns="0" rIns="0" bIns="0" anchor="ctr"/>
           <a:lstStyle xmlns:a="http://schemas.openxmlformats.org/drawingml/2006/main"/>
           <a:p xmlns:a="http://schemas.openxmlformats.org/drawingml/2006/main">
-            <a:pPr marL="0" indent="0">
+            <a:pPr marL="0" indent="0" algn="l">
               <a:buNone/>
+              <a:defRPr sz="900" b="0">
+                <a:solidFill>
+                  <a:srgbClr val="6B7C88"/>
+                </a:solidFill>
+              </a:defRPr>
             </a:pPr>
+            <a:r>
+              <a:rPr sz="900" b="0">
+                <a:solidFill>
+                  <a:srgbClr val="6B7C88"/>
+                </a:solidFill>
+              </a:rPr>
+              <a:t>Source: EU AI Act Annex III; Round 1 working view; legal validation remains open.</a:t>
+            </a:r>
             <a:endParaRPr sz="850"/>
           </a:p>
         </p:txBody>
@@ -6954,7 +7022,7 @@
           <p:nvPr/>
         </p:nvPicPr>
         <p:blipFill>
-          <a:blip xmlns:r="http://schemas.openxmlformats.org/officeDocument/2006/relationships" xmlns:a="http://schemas.openxmlformats.org/drawingml/2006/main" r:embed="R8a81df8573a04e21"/>
+          <a:blip xmlns:r="http://schemas.openxmlformats.org/officeDocument/2006/relationships" xmlns:a="http://schemas.openxmlformats.org/drawingml/2006/main" r:embed="Ree2210f3f94f46c4"/>
           <a:stretch xmlns:a="http://schemas.openxmlformats.org/drawingml/2006/main">
             <a:fillRect l="0" t="0" r="0" b="0"/>
           </a:stretch>
@@ -7174,9 +7242,22 @@
           <a:bodyPr xmlns:a="http://schemas.openxmlformats.org/drawingml/2006/main" wrap="square" lIns="0" tIns="0" rIns="0" bIns="0" anchor="ctr"/>
           <a:lstStyle xmlns:a="http://schemas.openxmlformats.org/drawingml/2006/main"/>
           <a:p xmlns:a="http://schemas.openxmlformats.org/drawingml/2006/main">
-            <a:pPr marL="0" indent="0">
+            <a:pPr marL="0" indent="0" algn="l">
               <a:buNone/>
+              <a:defRPr sz="900" b="0">
+                <a:solidFill>
+                  <a:srgbClr val="6B7C88"/>
+                </a:solidFill>
+              </a:defRPr>
             </a:pPr>
+            <a:r>
+              <a:rPr sz="900" b="0">
+                <a:solidFill>
+                  <a:srgbClr val="6B7C88"/>
+                </a:solidFill>
+              </a:rPr>
+              <a:t>Sources: CFPB, FCA, Financial Ombudsman Service, and project evaluation files.</a:t>
+            </a:r>
             <a:endParaRPr sz="850"/>
           </a:p>
         </p:txBody>
@@ -7508,7 +7589,7 @@
                             <a:srgbClr val="1B2730"/>
                           </a:solidFill>
                         </a:rPr>
-                        <a:t>CFPB public API, 2026-05-01 to 06-27</a:t>
+                        <a:t>U.S. Consumer Financial Protection Bureau (CFPB), 1 May–27 Jun 2026</a:t>
                       </a:r>
                       <a:endParaRPr sz="1050"/>
                     </a:p>
@@ -8255,7 +8336,7 @@
           <p:nvPr/>
         </p:nvPicPr>
         <p:blipFill>
-          <a:blip xmlns:r="http://schemas.openxmlformats.org/officeDocument/2006/relationships" xmlns:a="http://schemas.openxmlformats.org/drawingml/2006/main" r:embed="Rb19c9506a58b4f5a"/>
+          <a:blip xmlns:r="http://schemas.openxmlformats.org/officeDocument/2006/relationships" xmlns:a="http://schemas.openxmlformats.org/drawingml/2006/main" r:embed="R90326f3209cd47fa"/>
           <a:stretch xmlns:a="http://schemas.openxmlformats.org/drawingml/2006/main">
             <a:fillRect l="0" t="0" r="0" b="0"/>
           </a:stretch>
@@ -9322,7 +9403,7 @@
           <p:nvPr/>
         </p:nvPicPr>
         <p:blipFill>
-          <a:blip xmlns:r="http://schemas.openxmlformats.org/officeDocument/2006/relationships" xmlns:a="http://schemas.openxmlformats.org/drawingml/2006/main" r:embed="R501dae6cfb1f4df3"/>
+          <a:blip xmlns:r="http://schemas.openxmlformats.org/officeDocument/2006/relationships" xmlns:a="http://schemas.openxmlformats.org/drawingml/2006/main" r:embed="R810e605741cb4c66"/>
           <a:stretch xmlns:a="http://schemas.openxmlformats.org/drawingml/2006/main">
             <a:fillRect l="0" t="0" r="0" b="0"/>
           </a:stretch>
@@ -9442,9 +9523,22 @@
           <a:bodyPr xmlns:a="http://schemas.openxmlformats.org/drawingml/2006/main" wrap="square" lIns="0" tIns="0" rIns="0" bIns="0" anchor="ctr"/>
           <a:lstStyle xmlns:a="http://schemas.openxmlformats.org/drawingml/2006/main"/>
           <a:p xmlns:a="http://schemas.openxmlformats.org/drawingml/2006/main">
-            <a:pPr marL="0" indent="0">
+            <a:pPr marL="0" indent="0" algn="l">
               <a:buNone/>
+              <a:defRPr sz="900" b="0">
+                <a:solidFill>
+                  <a:srgbClr val="6B7C88"/>
+                </a:solidFill>
+              </a:defRPr>
             </a:pPr>
+            <a:r>
+              <a:rPr sz="900" b="0">
+                <a:solidFill>
+                  <a:srgbClr val="6B7C88"/>
+                </a:solidFill>
+              </a:rPr>
+              <a:t>Source: CFPB Consumer Complaint Database (public U.S. data; 1 May–27 Jun 2026).</a:t>
+            </a:r>
             <a:endParaRPr sz="850"/>
           </a:p>
         </p:txBody>
@@ -9504,7 +9598,7 @@
           <p:nvPr/>
         </p:nvPicPr>
         <p:blipFill>
-          <a:blip xmlns:r="http://schemas.openxmlformats.org/officeDocument/2006/relationships" xmlns:a="http://schemas.openxmlformats.org/drawingml/2006/main" r:embed="R14fc6e2c1bae4c89"/>
+          <a:blip xmlns:r="http://schemas.openxmlformats.org/officeDocument/2006/relationships" xmlns:a="http://schemas.openxmlformats.org/drawingml/2006/main" r:embed="R84080be2017a4bce"/>
           <a:stretch xmlns:a="http://schemas.openxmlformats.org/drawingml/2006/main">
             <a:fillRect l="0" t="0" r="0" b="0"/>
           </a:stretch>
@@ -9840,7 +9934,7 @@
           <p:nvPr/>
         </p:nvPicPr>
         <p:blipFill>
-          <a:blip xmlns:r="http://schemas.openxmlformats.org/officeDocument/2006/relationships" xmlns:a="http://schemas.openxmlformats.org/drawingml/2006/main" r:embed="R8a148e4e47ca48da"/>
+          <a:blip xmlns:r="http://schemas.openxmlformats.org/officeDocument/2006/relationships" xmlns:a="http://schemas.openxmlformats.org/drawingml/2006/main" r:embed="Rbecef9ec958e49ea"/>
           <a:stretch xmlns:a="http://schemas.openxmlformats.org/drawingml/2006/main">
             <a:fillRect l="0" t="0" r="0" b="0"/>
           </a:stretch>
@@ -9960,9 +10054,22 @@
           <a:bodyPr xmlns:a="http://schemas.openxmlformats.org/drawingml/2006/main" wrap="square" lIns="0" tIns="0" rIns="0" bIns="0" anchor="ctr"/>
           <a:lstStyle xmlns:a="http://schemas.openxmlformats.org/drawingml/2006/main"/>
           <a:p xmlns:a="http://schemas.openxmlformats.org/drawingml/2006/main">
-            <a:pPr marL="0" indent="0">
+            <a:pPr marL="0" indent="0" algn="l">
               <a:buNone/>
+              <a:defRPr sz="900" b="0">
+                <a:solidFill>
+                  <a:srgbClr val="6B7C88"/>
+                </a:solidFill>
+              </a:defRPr>
             </a:pPr>
+            <a:r>
+              <a:rPr sz="900" b="0">
+                <a:solidFill>
+                  <a:srgbClr val="6B7C88"/>
+                </a:solidFill>
+              </a:rPr>
+              <a:t>Source: Project demo/evaluation on public CFPB complaints; agreement is not accuracy.</a:t>
+            </a:r>
             <a:endParaRPr sz="850"/>
           </a:p>
         </p:txBody>
@@ -10022,7 +10129,7 @@
           <p:nvPr/>
         </p:nvPicPr>
         <p:blipFill>
-          <a:blip xmlns:r="http://schemas.openxmlformats.org/officeDocument/2006/relationships" xmlns:a="http://schemas.openxmlformats.org/drawingml/2006/main" r:embed="R537d6012df9d4478"/>
+          <a:blip xmlns:r="http://schemas.openxmlformats.org/officeDocument/2006/relationships" xmlns:a="http://schemas.openxmlformats.org/drawingml/2006/main" r:embed="Rb63f16244bda4fa8"/>
           <a:stretch xmlns:a="http://schemas.openxmlformats.org/drawingml/2006/main">
             <a:fillRect l="0" t="0" r="0" b="0"/>
           </a:stretch>
@@ -10046,7 +10153,7 @@
           <p:nvPr/>
         </p:nvPicPr>
         <p:blipFill>
-          <a:blip xmlns:r="http://schemas.openxmlformats.org/officeDocument/2006/relationships" xmlns:a="http://schemas.openxmlformats.org/drawingml/2006/main" r:embed="Rc9b513322889402d"/>
+          <a:blip xmlns:r="http://schemas.openxmlformats.org/officeDocument/2006/relationships" xmlns:a="http://schemas.openxmlformats.org/drawingml/2006/main" r:embed="Rfb0a7e79a69d41d1"/>
           <a:stretch xmlns:a="http://schemas.openxmlformats.org/drawingml/2006/main">
             <a:fillRect l="0" t="0" r="0" b="0"/>
           </a:stretch>
@@ -12083,7 +12190,7 @@
           <p:nvPr/>
         </p:nvPicPr>
         <p:blipFill>
-          <a:blip xmlns:r="http://schemas.openxmlformats.org/officeDocument/2006/relationships" xmlns:a="http://schemas.openxmlformats.org/drawingml/2006/main" r:embed="R50a2a327e09c4824"/>
+          <a:blip xmlns:r="http://schemas.openxmlformats.org/officeDocument/2006/relationships" xmlns:a="http://schemas.openxmlformats.org/drawingml/2006/main" r:embed="R1cec721bd7c54551"/>
           <a:stretch xmlns:a="http://schemas.openxmlformats.org/drawingml/2006/main">
             <a:fillRect l="0" t="0" r="0" b="0"/>
           </a:stretch>
@@ -12203,9 +12310,22 @@
           <a:bodyPr xmlns:a="http://schemas.openxmlformats.org/drawingml/2006/main" wrap="square" lIns="0" tIns="0" rIns="0" bIns="0" anchor="ctr"/>
           <a:lstStyle xmlns:a="http://schemas.openxmlformats.org/drawingml/2006/main"/>
           <a:p xmlns:a="http://schemas.openxmlformats.org/drawingml/2006/main">
-            <a:pPr marL="0" indent="0">
+            <a:pPr marL="0" indent="0" algn="l">
               <a:buNone/>
+              <a:defRPr sz="900" b="0">
+                <a:solidFill>
+                  <a:srgbClr val="6B7C88"/>
+                </a:solidFill>
+              </a:defRPr>
             </a:pPr>
+            <a:r>
+              <a:rPr sz="900" b="0">
+                <a:solidFill>
+                  <a:srgbClr val="6B7C88"/>
+                </a:solidFill>
+              </a:rPr>
+              <a:t>Sources: FCA complaint benchmark; Financial Ombudsman Service case fee; project cost model.</a:t>
+            </a:r>
             <a:endParaRPr sz="850"/>
           </a:p>
         </p:txBody>
@@ -13418,7 +13538,7 @@
           <p:nvPr/>
         </p:nvPicPr>
         <p:blipFill>
-          <a:blip xmlns:r="http://schemas.openxmlformats.org/officeDocument/2006/relationships" xmlns:a="http://schemas.openxmlformats.org/drawingml/2006/main" r:embed="R275f8c71fa7a42f2"/>
+          <a:blip xmlns:r="http://schemas.openxmlformats.org/officeDocument/2006/relationships" xmlns:a="http://schemas.openxmlformats.org/drawingml/2006/main" r:embed="Rf6c7ee433bda429f"/>
           <a:stretch xmlns:a="http://schemas.openxmlformats.org/drawingml/2006/main">
             <a:fillRect l="0" t="0" r="0" b="0"/>
           </a:stretch>
@@ -13642,7 +13762,7 @@
           <p:nvPr/>
         </p:nvPicPr>
         <p:blipFill>
-          <a:blip xmlns:r="http://schemas.openxmlformats.org/officeDocument/2006/relationships" xmlns:a="http://schemas.openxmlformats.org/drawingml/2006/main" r:embed="Rdd8a517d38d5495d"/>
+          <a:blip xmlns:r="http://schemas.openxmlformats.org/officeDocument/2006/relationships" xmlns:a="http://schemas.openxmlformats.org/drawingml/2006/main" r:embed="R380e739bb4934b50"/>
           <a:stretch xmlns:a="http://schemas.openxmlformats.org/drawingml/2006/main">
             <a:fillRect l="0" t="0" r="0" b="0"/>
           </a:stretch>
@@ -14447,7 +14567,7 @@
           <p:nvPr/>
         </p:nvPicPr>
         <p:blipFill>
-          <a:blip xmlns:r="http://schemas.openxmlformats.org/officeDocument/2006/relationships" xmlns:a="http://schemas.openxmlformats.org/drawingml/2006/main" r:embed="R5848d6bc4082462c"/>
+          <a:blip xmlns:r="http://schemas.openxmlformats.org/officeDocument/2006/relationships" xmlns:a="http://schemas.openxmlformats.org/drawingml/2006/main" r:embed="R6f2841d48071433e"/>
           <a:stretch xmlns:a="http://schemas.openxmlformats.org/drawingml/2006/main">
             <a:fillRect l="0" t="0" r="0" b="0"/>
           </a:stretch>
@@ -14667,9 +14787,22 @@
           <a:bodyPr xmlns:a="http://schemas.openxmlformats.org/drawingml/2006/main" wrap="square" lIns="0" tIns="0" rIns="0" bIns="0" anchor="ctr"/>
           <a:lstStyle xmlns:a="http://schemas.openxmlformats.org/drawingml/2006/main"/>
           <a:p xmlns:a="http://schemas.openxmlformats.org/drawingml/2006/main">
-            <a:pPr marL="0" indent="0">
+            <a:pPr marL="0" indent="0" algn="l">
               <a:buNone/>
+              <a:defRPr sz="900" b="0">
+                <a:solidFill>
+                  <a:srgbClr val="6B7C88"/>
+                </a:solidFill>
+              </a:defRPr>
             </a:pPr>
+            <a:r>
+              <a:rPr sz="900" b="0">
+                <a:solidFill>
+                  <a:srgbClr val="6B7C88"/>
+                </a:solidFill>
+              </a:rPr>
+              <a:t>Source: CFPB Consumer Complaint Database (public U.S. data; n=16,839).</a:t>
+            </a:r>
             <a:endParaRPr sz="850"/>
           </a:p>
         </p:txBody>
@@ -15310,7 +15443,7 @@
           <p:nvPr/>
         </p:nvPicPr>
         <p:blipFill>
-          <a:blip xmlns:r="http://schemas.openxmlformats.org/officeDocument/2006/relationships" xmlns:a="http://schemas.openxmlformats.org/drawingml/2006/main" r:embed="R0306a19abd3142e6"/>
+          <a:blip xmlns:r="http://schemas.openxmlformats.org/officeDocument/2006/relationships" xmlns:a="http://schemas.openxmlformats.org/drawingml/2006/main" r:embed="R13c84005b60948cb"/>
           <a:stretch xmlns:a="http://schemas.openxmlformats.org/drawingml/2006/main">
             <a:fillRect l="0" t="0" r="0" b="0"/>
           </a:stretch>
@@ -15530,9 +15663,22 @@
           <a:bodyPr xmlns:a="http://schemas.openxmlformats.org/drawingml/2006/main" wrap="square" lIns="0" tIns="0" rIns="0" bIns="0" anchor="ctr"/>
           <a:lstStyle xmlns:a="http://schemas.openxmlformats.org/drawingml/2006/main"/>
           <a:p xmlns:a="http://schemas.openxmlformats.org/drawingml/2006/main">
-            <a:pPr marL="0" indent="0">
+            <a:pPr marL="0" indent="0" algn="l">
               <a:buNone/>
+              <a:defRPr sz="900" b="0">
+                <a:solidFill>
+                  <a:srgbClr val="6B7C88"/>
+                </a:solidFill>
+              </a:defRPr>
             </a:pPr>
+            <a:r>
+              <a:rPr sz="900" b="0">
+                <a:solidFill>
+                  <a:srgbClr val="6B7C88"/>
+                </a:solidFill>
+              </a:rPr>
+              <a:t>Source: CFPB public data; monetary relief is a reported outcome, not handling cost.</a:t>
+            </a:r>
             <a:endParaRPr sz="850"/>
           </a:p>
         </p:txBody>

</xml_diff>

<commit_message>
Slide 4 claimed both screenshots were the same complaint. They are not
The caption read "The same demo case in LangSmith monitoring". The two panels show
different complaints:

  left  - checking or savings account, proposed to Disputes and fraud, passed
  right - credit card, stopped by the verbatim-quote check

Verified against n8n/sample_complaint.json and the record for cx_3a92b2805d197fb6
in langsmith/traces_export.json. No trace of the n8n complaint exists - it was run
through the workflow rather than the evaluation set - so the claim could not have
been made true by swapping an image.

Corrected to "A different case, stopped by the quote check", which is the better
slide anyway: the pair now shows one decision that passed and one the guard caught,
rather than the same thing twice. The spoken notes were already accurate about the
60-case evaluation; a clause was added so the pairing reads.

PDF re-rendered and speaker_notes.md synced so neither drifts from the deck.
</commit_message>
<xml_diff>
--- a/presentation/round1_pitch.pptx
+++ b/presentation/round1_pitch.pptx
@@ -1468,61 +1468,37 @@
               <a:t>Here is the demo workflow processing 1 public CFPB complaint. It proposes the Disputes and Fraud team, quotes the customer’s words as evidence, and stops for human review.</a:t>
             </a:r>
           </a:p>
-          <a:p xmlns:a="http://schemas.openxmlformats.org/drawingml/2006/main">
-            <a:r>
-              <a:t/>
-            </a:r>
-          </a:p>
-          <a:p xmlns:a="http://schemas.openxmlformats.org/drawingml/2006/main">
-            <a:r>
-              <a:t>LangSmith records every evaluation outcome. Of 60 cases, 52 produced a proposal; 4 stopped for low confidence and 4 because the quoted evidence was absent from the complaint.</a:t>
-            </a:r>
-          </a:p>
-          <a:p xmlns:a="http://schemas.openxmlformats.org/drawingml/2006/main">
-            <a:r>
-              <a:t/>
-            </a:r>
-          </a:p>
+          <a:p xmlns:a="http://schemas.openxmlformats.org/drawingml/2006/main"/>
+          <a:p xmlns:a="http://schemas.openxmlformats.org/drawingml/2006/main">
+            <a:r>
+              <a:t>On the right is a different case — one of the four the quote check stopped. LangSmith records every evaluation outcome. Of 60 cases, 52 produced a proposal; 4 stopped for low confidence and 4 because the quoted evidence was absent from the complaint.</a:t>
+            </a:r>
+          </a:p>
+          <a:p xmlns:a="http://schemas.openxmlformats.org/drawingml/2006/main"/>
           <a:p xmlns:a="http://schemas.openxmlformats.org/drawingml/2006/main">
             <a:r>
               <a:t>Those fabricated quotations matter most. Validation caught them and sent each case to human review.</a:t>
             </a:r>
           </a:p>
-          <a:p xmlns:a="http://schemas.openxmlformats.org/drawingml/2006/main">
-            <a:r>
-              <a:t/>
-            </a:r>
-          </a:p>
+          <a:p xmlns:a="http://schemas.openxmlformats.org/drawingml/2006/main"/>
           <a:p xmlns:a="http://schemas.openxmlformats.org/drawingml/2006/main">
             <a:r>
               <a:t>The broader evaluation produced 60.5% team-level agreement against consumer-selected CFPB labels. That is not deployment-quality evidence, and those labels are not expert routing decisions.</a:t>
             </a:r>
           </a:p>
-          <a:p xmlns:a="http://schemas.openxmlformats.org/drawingml/2006/main">
-            <a:r>
-              <a:t/>
-            </a:r>
-          </a:p>
+          <a:p xmlns:a="http://schemas.openxmlformats.org/drawingml/2006/main"/>
           <a:p xmlns:a="http://schemas.openxmlformats.org/drawingml/2006/main">
             <a:r>
               <a:t>The demo is observable, but it does not establish deployment accuracy. Phase 0 creates expert labels from your complaints; Phase 1 measures performance in shadow mode. That is why the proposal is staged.</a:t>
             </a:r>
           </a:p>
-          <a:p xmlns:a="http://schemas.openxmlformats.org/drawingml/2006/main">
-            <a:r>
-              <a:t/>
-            </a:r>
-          </a:p>
+          <a:p xmlns:a="http://schemas.openxmlformats.org/drawingml/2006/main"/>
           <a:p xmlns:a="http://schemas.openxmlformats.org/drawingml/2006/main">
             <a:r>
               <a:t>--- END OF SPOKEN NOTES ---</a:t>
             </a:r>
           </a:p>
-          <a:p xmlns:a="http://schemas.openxmlformats.org/drawingml/2006/main">
-            <a:r>
-              <a:t/>
-            </a:r>
-          </a:p>
+          <a:p xmlns:a="http://schemas.openxmlformats.org/drawingml/2006/main"/>
           <a:p xmlns:a="http://schemas.openxmlformats.org/drawingml/2006/main">
             <a:r>
               <a:t>[Sources]</a:t>
@@ -10438,7 +10414,7 @@
                 <a:ea typeface="Calibri"/>
                 <a:cs typeface="Calibri"/>
               </a:rPr>
-              <a:t>The same demo case in LangSmith monitoring</a:t>
+              <a:t>A different case, stopped by the quote check</a:t>
             </a:r>
             <a:endParaRPr sz="1050"/>
           </a:p>

</xml_diff>

<commit_message>
Harden Round 1 controls and pricing evidence
</commit_message>
<xml_diff>
--- a/presentation/round1_pitch.pptx
+++ b/presentation/round1_pitch.pptx
@@ -2,26 +2,26 @@
 <file path=ppt/presentation.xml><?xml version="1.0" encoding="utf-8"?>
 <p:presentation xmlns:p="http://schemas.openxmlformats.org/presentationml/2006/main">
   <p:sldMasterIdLst>
-    <p:sldMasterId xmlns:r="http://schemas.openxmlformats.org/officeDocument/2006/relationships" id="2147483648" r:id="R73b9547b469547b3"/>
+    <p:sldMasterId xmlns:r="http://schemas.openxmlformats.org/officeDocument/2006/relationships" id="2147483648" r:id="R9d2807a06f384cdb"/>
   </p:sldMasterIdLst>
   <p:notesMasterIdLst>
-    <p:notesMasterId xmlns:r="http://schemas.openxmlformats.org/officeDocument/2006/relationships" r:id="R56410e7f2b5445be"/>
+    <p:notesMasterId xmlns:r="http://schemas.openxmlformats.org/officeDocument/2006/relationships" r:id="R403896bc6b084b7d"/>
   </p:notesMasterIdLst>
   <p:sldIdLst>
-    <p:sldId xmlns:r="http://schemas.openxmlformats.org/officeDocument/2006/relationships" id="256" r:id="Rd26def38410049a6"/>
-    <p:sldId xmlns:r="http://schemas.openxmlformats.org/officeDocument/2006/relationships" id="257" r:id="R3b22b0014225498d"/>
-    <p:sldId xmlns:r="http://schemas.openxmlformats.org/officeDocument/2006/relationships" id="258" r:id="R2380e23fe235466c"/>
-    <p:sldId xmlns:r="http://schemas.openxmlformats.org/officeDocument/2006/relationships" id="259" r:id="R71735fc5ac9245f7"/>
-    <p:sldId xmlns:r="http://schemas.openxmlformats.org/officeDocument/2006/relationships" id="260" r:id="R4465b0b26c30493c"/>
-    <p:sldId xmlns:r="http://schemas.openxmlformats.org/officeDocument/2006/relationships" id="261" r:id="Ree76443202e54b62"/>
-    <p:sldId xmlns:r="http://schemas.openxmlformats.org/officeDocument/2006/relationships" id="262" r:id="Re572e4008d7043db"/>
-    <p:sldId xmlns:r="http://schemas.openxmlformats.org/officeDocument/2006/relationships" id="263" r:id="R91b3ac2167354724"/>
-    <p:sldId xmlns:r="http://schemas.openxmlformats.org/officeDocument/2006/relationships" id="264" r:id="R2f801f5078704be1"/>
-    <p:sldId xmlns:r="http://schemas.openxmlformats.org/officeDocument/2006/relationships" id="265" r:id="Reba12b63adad48d7"/>
-    <p:sldId xmlns:r="http://schemas.openxmlformats.org/officeDocument/2006/relationships" id="266" r:id="R752d83818c864954"/>
-    <p:sldId xmlns:r="http://schemas.openxmlformats.org/officeDocument/2006/relationships" id="267" r:id="R05b391fee938463e"/>
-    <p:sldId xmlns:r="http://schemas.openxmlformats.org/officeDocument/2006/relationships" id="268" r:id="R794c731530f349d4"/>
-    <p:sldId xmlns:r="http://schemas.openxmlformats.org/officeDocument/2006/relationships" id="269" r:id="R97516b331451472e"/>
+    <p:sldId xmlns:r="http://schemas.openxmlformats.org/officeDocument/2006/relationships" id="256" r:id="R8d40107ba5074ff6"/>
+    <p:sldId xmlns:r="http://schemas.openxmlformats.org/officeDocument/2006/relationships" id="257" r:id="Re2e44cd82f7c40e7"/>
+    <p:sldId xmlns:r="http://schemas.openxmlformats.org/officeDocument/2006/relationships" id="258" r:id="Rb81caf4f71294b8c"/>
+    <p:sldId xmlns:r="http://schemas.openxmlformats.org/officeDocument/2006/relationships" id="259" r:id="Rb16fa6dcbb634ad1"/>
+    <p:sldId xmlns:r="http://schemas.openxmlformats.org/officeDocument/2006/relationships" id="260" r:id="R157970933d754066"/>
+    <p:sldId xmlns:r="http://schemas.openxmlformats.org/officeDocument/2006/relationships" id="261" r:id="R49900bb5ba91447e"/>
+    <p:sldId xmlns:r="http://schemas.openxmlformats.org/officeDocument/2006/relationships" id="262" r:id="R3dce50c4ee504be7"/>
+    <p:sldId xmlns:r="http://schemas.openxmlformats.org/officeDocument/2006/relationships" id="263" r:id="R6741b140f4c743f6"/>
+    <p:sldId xmlns:r="http://schemas.openxmlformats.org/officeDocument/2006/relationships" id="264" r:id="R407db62e5d234ef3"/>
+    <p:sldId xmlns:r="http://schemas.openxmlformats.org/officeDocument/2006/relationships" id="265" r:id="R0b963aed4d804c3e"/>
+    <p:sldId xmlns:r="http://schemas.openxmlformats.org/officeDocument/2006/relationships" id="266" r:id="Rbab79592a96941b0"/>
+    <p:sldId xmlns:r="http://schemas.openxmlformats.org/officeDocument/2006/relationships" id="267" r:id="R093fe636ed794a0b"/>
+    <p:sldId xmlns:r="http://schemas.openxmlformats.org/officeDocument/2006/relationships" id="268" r:id="R4ba3e3e41e1b474c"/>
+    <p:sldId xmlns:r="http://schemas.openxmlformats.org/officeDocument/2006/relationships" id="269" r:id="R279bdc1448ee450a"/>
   </p:sldIdLst>
   <p:sldSz cx="12192000" cy="6858000"/>
   <p:notesSz cx="6858000" cy="9144000"/>
@@ -620,7 +620,7 @@
           <a:lstStyle xmlns:a="http://schemas.openxmlformats.org/drawingml/2006/main"/>
           <a:p xmlns:a="http://schemas.openxmlformats.org/drawingml/2006/main">
             <a:r>
-              <a:t>The 60.5% result should not be interpreted as a clean measure of model accuracy.</a:t>
+              <a:t>In the 60-case evaluation sample recorded in LangSmith, 52 complaints produced a proposal after passing the configured validation checks. Passing those checks does not prove that the proposed team was correct.</a:t>
             </a:r>
           </a:p>
           <a:p xmlns:a="http://schemas.openxmlformats.org/drawingml/2006/main">
@@ -630,7 +630,7 @@
           </a:p>
           <a:p xmlns:a="http://schemas.openxmlformats.org/drawingml/2006/main">
             <a:r>
-              <a:t>When the same model classified the same complaints again, it selected the same team approximately 89% of the time. It was relatively consistent with itself but disagreed much more often with the CFPB label.</a:t>
+              <a:t>4 were flagged for human review because the model’s evidence quotation was not present verbatim in the complaint. Another 4 were flagged because confidence was below the threshold.</a:t>
             </a:r>
           </a:p>
           <a:p xmlns:a="http://schemas.openxmlformats.org/drawingml/2006/main">
@@ -640,7 +640,7 @@
           </a:p>
           <a:p xmlns:a="http://schemas.openxmlformats.org/drawingml/2006/main">
             <a:r>
-              <a:t>The CFPB issue label is selected by the person filing the complaint, using a product-specific menu. It is not an expert judgement about which internal team should handle the case.</a:t>
+              <a:t>Every case in the sample has a recorded outcome and a reason code. 0 cases lack a recorded outcome.</a:t>
             </a:r>
           </a:p>
           <a:p xmlns:a="http://schemas.openxmlformats.org/drawingml/2006/main">
@@ -650,7 +650,7 @@
           </a:p>
           <a:p xmlns:a="http://schemas.openxmlformats.org/drawingml/2006/main">
             <a:r>
-              <a:t>The 60.5% result therefore mixes model error with label mismatch; it cannot separate them. Phase 0 resolves that uncertainty by asking experienced handlers to create an expert-labelled reference set and by measuring their agreement with one another.</a:t>
+              <a:t>This does not prove that every proposal was correct. It proves that proposals and stops can be traced and discussed.</a:t>
             </a:r>
           </a:p>
           <a:p xmlns:a="http://schemas.openxmlformats.org/drawingml/2006/main">
@@ -675,12 +675,7 @@
           </a:p>
           <a:p xmlns:a="http://schemas.openxmlformats.org/drawingml/2006/main">
             <a:r>
-              <a:t>- Project repository: classifier/eval_results_gpt-4o.json.</a:t>
-            </a:r>
-          </a:p>
-          <a:p xmlns:a="http://schemas.openxmlformats.org/drawingml/2006/main">
-            <a:r>
-              <a:t>- Project repository: classifier/FINDINGS.md.</a:t>
+              <a:t>- Project repository: langsmith/experiment_summary.json.</a:t>
             </a:r>
           </a:p>
           <a:p xmlns:a="http://schemas.openxmlformats.org/drawingml/2006/main">
@@ -755,7 +750,7 @@
           <a:lstStyle xmlns:a="http://schemas.openxmlformats.org/drawingml/2006/main"/>
           <a:p xmlns:a="http://schemas.openxmlformats.org/drawingml/2006/main">
             <a:r>
-              <a:t>3 data problems could have produced confident but misleading conclusions.</a:t>
+              <a:t>The 60.5% result should not be interpreted as a clean measure of model accuracy.</a:t>
             </a:r>
           </a:p>
           <a:p xmlns:a="http://schemas.openxmlformats.org/drawingml/2006/main">
@@ -765,7 +760,7 @@
           </a:p>
           <a:p xmlns:a="http://schemas.openxmlformats.org/drawingml/2006/main">
             <a:r>
-              <a:t>First, recent complaint volume appeared to collapse by 73% because the CFPB publishes complaints only after the company responds or enough time passes. I removed the incomplete period and ended the analysis window on 27 June 2026.</a:t>
+              <a:t>When the same model classified the same complaints again, it selected the same team approximately 89% of the time. It was relatively consistent with itself but disagreed much more often with the CFPB label.</a:t>
             </a:r>
           </a:p>
           <a:p xmlns:a="http://schemas.openxmlformats.org/drawingml/2006/main">
@@ -775,7 +770,7 @@
           </a:p>
           <a:p xmlns:a="http://schemas.openxmlformats.org/drawingml/2006/main">
             <a:r>
-              <a:t>Second, the apparent response-time field was 0 for 96% of records because it measured the regulator’s routing process, not the firm’s handling time. I excluded it.</a:t>
+              <a:t>The CFPB issue label is selected by the person filing the complaint, using a product-specific menu. It is not an expert judgement about which internal team should handle the case.</a:t>
             </a:r>
           </a:p>
           <a:p xmlns:a="http://schemas.openxmlformats.org/drawingml/2006/main">
@@ -785,7 +780,7 @@
           </a:p>
           <a:p xmlns:a="http://schemas.openxmlformats.org/drawingml/2006/main">
             <a:r>
-              <a:t>Third, 2 different timeliness fields created apparently conflicting percentages. I separated their meanings instead of treating them as the same metric.</a:t>
+              <a:t>The 60.5% result therefore mixes model error with label mismatch; it cannot separate them. Phase 0 resolves that uncertainty by asking experienced handlers to create an expert-labelled reference set and by measuring their agreement with one another.</a:t>
             </a:r>
           </a:p>
           <a:p xmlns:a="http://schemas.openxmlformats.org/drawingml/2006/main">
@@ -795,7 +790,7 @@
           </a:p>
           <a:p xmlns:a="http://schemas.openxmlformats.org/drawingml/2006/main">
             <a:r>
-              <a:t>The lesson is that a field can be complete and still mean the wrong thing for the business question.</a:t>
+              <a:t>--- END OF SPOKEN NOTES ---</a:t>
             </a:r>
           </a:p>
           <a:p xmlns:a="http://schemas.openxmlformats.org/drawingml/2006/main">
@@ -805,22 +800,27 @@
           </a:p>
           <a:p xmlns:a="http://schemas.openxmlformats.org/drawingml/2006/main">
             <a:r>
-              <a:t>--- END OF SPOKEN NOTES ---</a:t>
-            </a:r>
-          </a:p>
-          <a:p xmlns:a="http://schemas.openxmlformats.org/drawingml/2006/main">
-            <a:r>
-              <a:t/>
-            </a:r>
-          </a:p>
-          <a:p xmlns:a="http://schemas.openxmlformats.org/drawingml/2006/main">
-            <a:r>
               <a:t>[Sources]</a:t>
             </a:r>
           </a:p>
           <a:p xmlns:a="http://schemas.openxmlformats.org/drawingml/2006/main">
             <a:r>
-              <a:t>- Project repository: README.md and the documented data-quality checks.</a:t>
+              <a:t>- Project repository: classifier/eval_results_gpt-4o.json and classifier/eval_results_gpt-4o-mini.json.</a:t>
+            </a:r>
+          </a:p>
+          <a:p xmlns:a="http://schemas.openxmlformats.org/drawingml/2006/main">
+            <a:r>
+              <a:t>- Project repository: classifier/FINDINGS.md and cost_estimation/cost_model.json.</a:t>
+            </a:r>
+          </a:p>
+          <a:p xmlns:a="http://schemas.openxmlformats.org/drawingml/2006/main">
+            <a:r>
+              <a:t>- OpenAI GPT-4o pricing: https://developers.openai.com/api/docs/models/gpt-4o</a:t>
+            </a:r>
+          </a:p>
+          <a:p xmlns:a="http://schemas.openxmlformats.org/drawingml/2006/main">
+            <a:r>
+              <a:t>- OpenAI GPT-4o-mini pricing: https://developers.openai.com/api/docs/models/gpt-4o-mini</a:t>
             </a:r>
           </a:p>
           <a:p xmlns:a="http://schemas.openxmlformats.org/drawingml/2006/main">
@@ -895,7 +895,7 @@
           <a:lstStyle xmlns:a="http://schemas.openxmlformats.org/drawingml/2006/main"/>
           <a:p xmlns:a="http://schemas.openxmlformats.org/drawingml/2006/main">
             <a:r>
-              <a:t>My Round 1 compliance position is deliberately preliminary. It is not a final legal classification.</a:t>
+              <a:t>3 data problems could have produced confident but misleading conclusions.</a:t>
             </a:r>
           </a:p>
           <a:p xmlns:a="http://schemas.openxmlformats.org/drawingml/2006/main">
@@ -905,7 +905,7 @@
           </a:p>
           <a:p xmlns:a="http://schemas.openxmlformats.org/drawingml/2006/main">
             <a:r>
-              <a:t>This system proposes an internal complaint-routing team. It does not assess creditworthiness, determine access to a financial service, or make the final decision on a customer’s complaint. A human remains responsible for confirming the route and resolving the case.</a:t>
+              <a:t>First, recent complaint volume appeared to collapse by 73% because the CFPB publishes complaints only after the company responds or enough time passes. I removed the incomplete period and ended the analysis window on 27 June 2026.</a:t>
             </a:r>
           </a:p>
           <a:p xmlns:a="http://schemas.openxmlformats.org/drawingml/2006/main">
@@ -915,7 +915,7 @@
           </a:p>
           <a:p xmlns:a="http://schemas.openxmlformats.org/drawingml/2006/main">
             <a:r>
-              <a:t>On that intended use, I have not identified it as matching the Annex III creditworthiness use classified as high-risk. However, classification depends on the exact intended purpose, deployment context, data flows, and degree of human control.</a:t>
+              <a:t>Second, the apparent response-time field was 0 for 96% of records because it measured the regulator’s routing process, not the firm’s handling time. I excluded it.</a:t>
             </a:r>
           </a:p>
           <a:p xmlns:a="http://schemas.openxmlformats.org/drawingml/2006/main">
@@ -925,7 +925,7 @@
           </a:p>
           <a:p xmlns:a="http://schemas.openxmlformats.org/drawingml/2006/main">
             <a:r>
-              <a:t>Round 2 therefore needs a step-by-step classification and obligations assessment. If the system begins routing automatically or influencing substantive customer outcomes, that is a new assessment, not a minor product upgrade.</a:t>
+              <a:t>Third, 2 different timeliness fields created apparently conflicting percentages. I separated their meanings instead of treating them as the same metric.</a:t>
             </a:r>
           </a:p>
           <a:p xmlns:a="http://schemas.openxmlformats.org/drawingml/2006/main">
@@ -935,7 +935,7 @@
           </a:p>
           <a:p xmlns:a="http://schemas.openxmlformats.org/drawingml/2006/main">
             <a:r>
-              <a:t>Round 2 must also establish the GDPR legal basis and retention period, decide whether a DPIA is required, and verify the hosting region and cross-border transfer controls. Those controls are open work, not completed safeguards.</a:t>
+              <a:t>The lesson is that a field can be complete and still mean the wrong thing for the business question.</a:t>
             </a:r>
           </a:p>
           <a:p xmlns:a="http://schemas.openxmlformats.org/drawingml/2006/main">
@@ -960,12 +960,7 @@
           </a:p>
           <a:p xmlns:a="http://schemas.openxmlformats.org/drawingml/2006/main">
             <a:r>
-              <a:t>- Project repository: research/opportunities_risks.md, §4.</a:t>
-            </a:r>
-          </a:p>
-          <a:p xmlns:a="http://schemas.openxmlformats.org/drawingml/2006/main">
-            <a:r>
-              <a:t>- EU AI Act: https://eur-lex.europa.eu/eli/reg/2024/1689/oj</a:t>
+              <a:t>- Project repository: README.md and the documented data-quality checks.</a:t>
             </a:r>
           </a:p>
           <a:p xmlns:a="http://schemas.openxmlformats.org/drawingml/2006/main">
@@ -1040,6 +1035,151 @@
           <a:lstStyle xmlns:a="http://schemas.openxmlformats.org/drawingml/2006/main"/>
           <a:p xmlns:a="http://schemas.openxmlformats.org/drawingml/2006/main">
             <a:r>
+              <a:t>My Round 1 compliance position is deliberately preliminary. It is not a final legal classification.</a:t>
+            </a:r>
+          </a:p>
+          <a:p xmlns:a="http://schemas.openxmlformats.org/drawingml/2006/main">
+            <a:r>
+              <a:t/>
+            </a:r>
+          </a:p>
+          <a:p xmlns:a="http://schemas.openxmlformats.org/drawingml/2006/main">
+            <a:r>
+              <a:t>This system proposes an internal complaint-routing team. It does not assess creditworthiness, determine access to a financial service, or make the final decision on a customer’s complaint. A human remains responsible for confirming the route and resolving the case.</a:t>
+            </a:r>
+          </a:p>
+          <a:p xmlns:a="http://schemas.openxmlformats.org/drawingml/2006/main">
+            <a:r>
+              <a:t/>
+            </a:r>
+          </a:p>
+          <a:p xmlns:a="http://schemas.openxmlformats.org/drawingml/2006/main">
+            <a:r>
+              <a:t>On that intended use, I have not identified it as matching the Annex III creditworthiness use classified as high-risk. However, classification depends on the exact intended purpose, deployment context, data flows, and degree of human control.</a:t>
+            </a:r>
+          </a:p>
+          <a:p xmlns:a="http://schemas.openxmlformats.org/drawingml/2006/main">
+            <a:r>
+              <a:t/>
+            </a:r>
+          </a:p>
+          <a:p xmlns:a="http://schemas.openxmlformats.org/drawingml/2006/main">
+            <a:r>
+              <a:t>Round 2 therefore needs a step-by-step classification and obligations assessment. If the system begins routing automatically or influencing substantive customer outcomes, that is a new assessment, not a minor product upgrade.</a:t>
+            </a:r>
+          </a:p>
+          <a:p xmlns:a="http://schemas.openxmlformats.org/drawingml/2006/main">
+            <a:r>
+              <a:t/>
+            </a:r>
+          </a:p>
+          <a:p xmlns:a="http://schemas.openxmlformats.org/drawingml/2006/main">
+            <a:r>
+              <a:t>Round 2 must also establish the GDPR legal basis and retention period, decide whether a DPIA is required, and verify the hosting region and cross-border transfer controls. Those controls are open work, not completed safeguards.</a:t>
+            </a:r>
+          </a:p>
+          <a:p xmlns:a="http://schemas.openxmlformats.org/drawingml/2006/main">
+            <a:r>
+              <a:t/>
+            </a:r>
+          </a:p>
+          <a:p xmlns:a="http://schemas.openxmlformats.org/drawingml/2006/main">
+            <a:r>
+              <a:t>--- END OF SPOKEN NOTES ---</a:t>
+            </a:r>
+          </a:p>
+          <a:p xmlns:a="http://schemas.openxmlformats.org/drawingml/2006/main">
+            <a:r>
+              <a:t/>
+            </a:r>
+          </a:p>
+          <a:p xmlns:a="http://schemas.openxmlformats.org/drawingml/2006/main">
+            <a:r>
+              <a:t>[Sources]</a:t>
+            </a:r>
+          </a:p>
+          <a:p xmlns:a="http://schemas.openxmlformats.org/drawingml/2006/main">
+            <a:r>
+              <a:t>- Project repository: research/opportunities_risks.md, §4.</a:t>
+            </a:r>
+          </a:p>
+          <a:p xmlns:a="http://schemas.openxmlformats.org/drawingml/2006/main">
+            <a:r>
+              <a:t>- EU AI Act: https://eur-lex.europa.eu/eli/reg/2024/1689/oj</a:t>
+            </a:r>
+          </a:p>
+          <a:p xmlns:a="http://schemas.openxmlformats.org/drawingml/2006/main">
+            <a:r>
+              <a:t>[/Sources]</a:t>
+            </a:r>
+          </a:p>
+        </p:txBody>
+      </p:sp>
+      <p:sp>
+        <p:nvSpPr>
+          <p:cNvPr id="4" name="Slide Number Placeholder 3"/>
+          <p:cNvSpPr>
+            <a:spLocks xmlns:a="http://schemas.openxmlformats.org/drawingml/2006/main" noGrp="1"/>
+          </p:cNvSpPr>
+          <p:nvPr>
+            <p:ph type="sldNum" idx="5"/>
+          </p:nvPr>
+        </p:nvSpPr>
+        <p:spPr/>
+        <p:txBody>
+          <a:bodyPr xmlns:a="http://schemas.openxmlformats.org/drawingml/2006/main"/>
+          <a:lstStyle xmlns:a="http://schemas.openxmlformats.org/drawingml/2006/main"/>
+          <a:p xmlns:a="http://schemas.openxmlformats.org/drawingml/2006/main"/>
+        </p:txBody>
+      </p:sp>
+    </p:spTree>
+  </p:cSld>
+  <p:clrMapOvr>
+    <a:masterClrMapping xmlns:a="http://schemas.openxmlformats.org/drawingml/2006/main"/>
+  </p:clrMapOvr>
+</p:notes>
+</file>
+
+<file path=ppt/notesSlides/notesSlide14.xml><?xml version="1.0" encoding="utf-8"?>
+<p:notes xmlns:p="http://schemas.openxmlformats.org/presentationml/2006/main">
+  <p:cSld>
+    <p:spTree>
+      <p:nvGrpSpPr>
+        <p:cNvPr id="1" name=""/>
+        <p:cNvGrpSpPr/>
+        <p:nvPr/>
+      </p:nvGrpSpPr>
+      <p:grpSpPr>
+        <a:xfrm xmlns:a="http://schemas.openxmlformats.org/drawingml/2006/main"/>
+      </p:grpSpPr>
+      <p:sp>
+        <p:nvSpPr>
+          <p:cNvPr id="2" name="Slide Image Placeholder 1"/>
+          <p:cNvSpPr>
+            <a:spLocks xmlns:a="http://schemas.openxmlformats.org/drawingml/2006/main" noGrp="1"/>
+          </p:cNvSpPr>
+          <p:nvPr>
+            <p:ph type="sldImg" idx="0"/>
+          </p:nvPr>
+        </p:nvSpPr>
+        <p:spPr/>
+      </p:sp>
+      <p:sp>
+        <p:nvSpPr>
+          <p:cNvPr id="3" name="Notes Placeholder 2"/>
+          <p:cNvSpPr>
+            <a:spLocks xmlns:a="http://schemas.openxmlformats.org/drawingml/2006/main" noGrp="1"/>
+          </p:cNvSpPr>
+          <p:nvPr>
+            <p:ph type="body" idx="1"/>
+          </p:nvPr>
+        </p:nvSpPr>
+        <p:spPr/>
+        <p:txBody>
+          <a:bodyPr xmlns:a="http://schemas.openxmlformats.org/drawingml/2006/main"/>
+          <a:lstStyle xmlns:a="http://schemas.openxmlformats.org/drawingml/2006/main"/>
+          <a:p xmlns:a="http://schemas.openxmlformats.org/drawingml/2006/main">
+            <a:r>
               <a:t>Every figure in the pitch fits 1 of 3 categories: measured in this project, taken from a named public source, or explicitly labelled as an assumption or professional judgement.</a:t>
             </a:r>
           </a:p>
@@ -1465,40 +1605,64 @@
           <a:lstStyle xmlns:a="http://schemas.openxmlformats.org/drawingml/2006/main"/>
           <a:p xmlns:a="http://schemas.openxmlformats.org/drawingml/2006/main">
             <a:r>
-              <a:t>Here is the demo workflow processing 1 public CFPB complaint. It proposes the Disputes and Fraud team, quotes the customer’s words as evidence, and stops for human review.</a:t>
-            </a:r>
-          </a:p>
-          <a:p xmlns:a="http://schemas.openxmlformats.org/drawingml/2006/main"/>
-          <a:p xmlns:a="http://schemas.openxmlformats.org/drawingml/2006/main">
-            <a:r>
-              <a:t>On the right is a different case — one of the four the quote check stopped. LangSmith records every evaluation outcome. Of 60 cases, 52 produced a proposal; 4 stopped for low confidence and 4 because the quoted evidence was absent from the complaint.</a:t>
-            </a:r>
-          </a:p>
-          <a:p xmlns:a="http://schemas.openxmlformats.org/drawingml/2006/main"/>
+              <a:t>Here is the demo workflow processing 1 public CFPB complaint. It proposes the Disputes and Fraud team, quotes the customer’s words as evidence, and leaves the routing decision to a person.</a:t>
+            </a:r>
+          </a:p>
+          <a:p xmlns:a="http://schemas.openxmlformats.org/drawingml/2006/main">
+            <a:r>
+              <a:t/>
+            </a:r>
+          </a:p>
+          <a:p xmlns:a="http://schemas.openxmlformats.org/drawingml/2006/main">
+            <a:r>
+              <a:t>On the right is a different case — 1 of the 4 stopped by the quote check. LangSmith records every evaluation outcome. Of 60 cases, 52 produced a proposal; 4 stopped for low confidence and 4 because the quoted evidence was absent from the complaint.</a:t>
+            </a:r>
+          </a:p>
+          <a:p xmlns:a="http://schemas.openxmlformats.org/drawingml/2006/main">
+            <a:r>
+              <a:t/>
+            </a:r>
+          </a:p>
           <a:p xmlns:a="http://schemas.openxmlformats.org/drawingml/2006/main">
             <a:r>
               <a:t>Those fabricated quotations matter most. Validation caught them and sent each case to human review.</a:t>
             </a:r>
           </a:p>
-          <a:p xmlns:a="http://schemas.openxmlformats.org/drawingml/2006/main"/>
+          <a:p xmlns:a="http://schemas.openxmlformats.org/drawingml/2006/main">
+            <a:r>
+              <a:t/>
+            </a:r>
+          </a:p>
           <a:p xmlns:a="http://schemas.openxmlformats.org/drawingml/2006/main">
             <a:r>
               <a:t>The broader evaluation produced 60.5% team-level agreement against consumer-selected CFPB labels. That is not deployment-quality evidence, and those labels are not expert routing decisions.</a:t>
             </a:r>
           </a:p>
-          <a:p xmlns:a="http://schemas.openxmlformats.org/drawingml/2006/main"/>
+          <a:p xmlns:a="http://schemas.openxmlformats.org/drawingml/2006/main">
+            <a:r>
+              <a:t/>
+            </a:r>
+          </a:p>
           <a:p xmlns:a="http://schemas.openxmlformats.org/drawingml/2006/main">
             <a:r>
               <a:t>The demo is observable, but it does not establish deployment accuracy. Phase 0 creates expert labels from your complaints; Phase 1 measures performance in shadow mode. That is why the proposal is staged.</a:t>
             </a:r>
           </a:p>
-          <a:p xmlns:a="http://schemas.openxmlformats.org/drawingml/2006/main"/>
+          <a:p xmlns:a="http://schemas.openxmlformats.org/drawingml/2006/main">
+            <a:r>
+              <a:t/>
+            </a:r>
+          </a:p>
           <a:p xmlns:a="http://schemas.openxmlformats.org/drawingml/2006/main">
             <a:r>
               <a:t>--- END OF SPOKEN NOTES ---</a:t>
             </a:r>
           </a:p>
-          <a:p xmlns:a="http://schemas.openxmlformats.org/drawingml/2006/main"/>
+          <a:p xmlns:a="http://schemas.openxmlformats.org/drawingml/2006/main">
+            <a:r>
+              <a:t/>
+            </a:r>
+          </a:p>
           <a:p xmlns:a="http://schemas.openxmlformats.org/drawingml/2006/main">
             <a:r>
               <a:t>[Sources]</a:t>
@@ -1506,7 +1670,17 @@
           </a:p>
           <a:p xmlns:a="http://schemas.openxmlformats.org/drawingml/2006/main">
             <a:r>
-              <a:t>- Project repository: langsmith/experiment_summary.json.</a:t>
+              <a:t>- Project asset: n8n/screenshots/n8n-execution.png.</a:t>
+            </a:r>
+          </a:p>
+          <a:p xmlns:a="http://schemas.openxmlformats.org/drawingml/2006/main">
+            <a:r>
+              <a:t>- Project asset: langsmith/screenshots/trace-detail-guard-fired.png.</a:t>
+            </a:r>
+          </a:p>
+          <a:p xmlns:a="http://schemas.openxmlformats.org/drawingml/2006/main">
+            <a:r>
+              <a:t>- Project repository: langsmith/traces_export.json and langsmith/experiment_summary.json.</a:t>
             </a:r>
           </a:p>
           <a:p xmlns:a="http://schemas.openxmlformats.org/drawingml/2006/main">
@@ -1686,6 +1860,11 @@
           </a:p>
           <a:p xmlns:a="http://schemas.openxmlformats.org/drawingml/2006/main">
             <a:r>
+              <a:t>- OpenAI GPT-4o-mini pricing: https://developers.openai.com/api/docs/models/gpt-4o-mini</a:t>
+            </a:r>
+          </a:p>
+          <a:p xmlns:a="http://schemas.openxmlformats.org/drawingml/2006/main">
+            <a:r>
               <a:t>- Financial Ombudsman Service case fees: https://www.financial-ombudsman.org.uk/businesses/resolving-complaint/case-fees</a:t>
             </a:r>
           </a:p>
@@ -1759,76 +1938,7 @@
         <p:txBody>
           <a:bodyPr xmlns:a="http://schemas.openxmlformats.org/drawingml/2006/main"/>
           <a:lstStyle xmlns:a="http://schemas.openxmlformats.org/drawingml/2006/main"/>
-          <a:p xmlns:a="http://schemas.openxmlformats.org/drawingml/2006/main">
-            <a:r>
-              <a:t>I ranked 3 candidate use cases by how visible and controllable their reasoning can be. Only complaint triage is proposed for Phase 0 and Phase 1; anomaly flagging and reporting assistance remain later options.</a:t>
-            </a:r>
-          </a:p>
-          <a:p xmlns:a="http://schemas.openxmlformats.org/drawingml/2006/main">
-            <a:r>
-              <a:t/>
-            </a:r>
-          </a:p>
-          <a:p xmlns:a="http://schemas.openxmlformats.org/drawingml/2006/main">
-            <a:r>
-              <a:t>Complaint triage can propose a team and show the exact evidence behind the proposal. Anomaly flagging can identify unusual patterns for one of your investigators to review. Reporting assistance can draft material while leaving approval with a named employee in your firm.</a:t>
-            </a:r>
-          </a:p>
-          <a:p xmlns:a="http://schemas.openxmlformats.org/drawingml/2006/main">
-            <a:r>
-              <a:t/>
-            </a:r>
-          </a:p>
-          <a:p xmlns:a="http://schemas.openxmlformats.org/drawingml/2006/main">
-            <a:r>
-              <a:t>I ruled out 2 uses. A customer-facing chatbot could make public errors in the firm’s voice. Creditworthiness scoring directly affects access to financial services and is classified as high-risk under the EU AI Act. A separate guardrail prevents predicted payout from determining routing priority.</a:t>
-            </a:r>
-          </a:p>
-          <a:p xmlns:a="http://schemas.openxmlformats.org/drawingml/2006/main">
-            <a:r>
-              <a:t/>
-            </a:r>
-          </a:p>
-          <a:p xmlns:a="http://schemas.openxmlformats.org/drawingml/2006/main">
-            <a:r>
-              <a:t>The point is not to find the most impressive use case. It is to choose a use case whose risks can be bounded and whose decisions can be examined.</a:t>
-            </a:r>
-          </a:p>
-          <a:p xmlns:a="http://schemas.openxmlformats.org/drawingml/2006/main">
-            <a:r>
-              <a:t/>
-            </a:r>
-          </a:p>
-          <a:p xmlns:a="http://schemas.openxmlformats.org/drawingml/2006/main">
-            <a:r>
-              <a:t>--- END OF SPOKEN NOTES ---</a:t>
-            </a:r>
-          </a:p>
-          <a:p xmlns:a="http://schemas.openxmlformats.org/drawingml/2006/main">
-            <a:r>
-              <a:t/>
-            </a:r>
-          </a:p>
-          <a:p xmlns:a="http://schemas.openxmlformats.org/drawingml/2006/main">
-            <a:r>
-              <a:t>[Sources]</a:t>
-            </a:r>
-          </a:p>
-          <a:p xmlns:a="http://schemas.openxmlformats.org/drawingml/2006/main">
-            <a:r>
-              <a:t>- Project repository: research/use_cases.md.</a:t>
-            </a:r>
-          </a:p>
-          <a:p xmlns:a="http://schemas.openxmlformats.org/drawingml/2006/main">
-            <a:r>
-              <a:t>- EU AI Act, Annex III: https://eur-lex.europa.eu/eli/reg/2024/1689/oj</a:t>
-            </a:r>
-          </a:p>
-          <a:p xmlns:a="http://schemas.openxmlformats.org/drawingml/2006/main">
-            <a:r>
-              <a:t>[/Sources]</a:t>
-            </a:r>
-          </a:p>
+          <a:p xmlns:a="http://schemas.openxmlformats.org/drawingml/2006/main"/>
         </p:txBody>
       </p:sp>
       <p:sp>
@@ -1896,7 +2006,7 @@
           <a:lstStyle xmlns:a="http://schemas.openxmlformats.org/drawingml/2006/main"/>
           <a:p xmlns:a="http://schemas.openxmlformats.org/drawingml/2006/main">
             <a:r>
-              <a:t>This chart explains how the public data supports a bounded initial test.</a:t>
+              <a:t>I ranked 3 candidate use cases by how visible and controllable their reasoning can be. Only complaint triage is proposed for Phase 0 and Phase 1; anomaly flagging and reporting assistance remain later options.</a:t>
             </a:r>
           </a:p>
           <a:p xmlns:a="http://schemas.openxmlformats.org/drawingml/2006/main">
@@ -1906,7 +2016,7 @@
           </a:p>
           <a:p xmlns:a="http://schemas.openxmlformats.org/drawingml/2006/main">
             <a:r>
-              <a:t>In the public dataset, 5 of 64 issue categories account for 46.1% of complaints. That makes it possible to test a narrow, high-volume starting point instead of pretending the model can handle the entire taxonomy equally well.</a:t>
+              <a:t>Complaint triage can propose a team and show the exact evidence behind the proposal. Anomaly flagging can identify unusual patterns for one of your investigators to review. Reporting assistance can draft material while leaving approval with a named employee in your firm.</a:t>
             </a:r>
           </a:p>
           <a:p xmlns:a="http://schemas.openxmlformats.org/drawingml/2006/main">
@@ -1916,7 +2026,7 @@
           </a:p>
           <a:p xmlns:a="http://schemas.openxmlformats.org/drawingml/2006/main">
             <a:r>
-              <a:t>I would not assume that 46.1% applies to the client. Phase 0 must measure the client’s own concentration and decide which categories belong in the pilot.</a:t>
+              <a:t>I ruled out 2 uses. A customer-facing chatbot could make public errors in the firm’s voice. Creditworthiness scoring directly affects access to financial services and is classified as high-risk under the EU AI Act. A separate guardrail prevents predicted payout from determining routing priority.</a:t>
             </a:r>
           </a:p>
           <a:p xmlns:a="http://schemas.openxmlformats.org/drawingml/2006/main">
@@ -1926,7 +2036,7 @@
           </a:p>
           <a:p xmlns:a="http://schemas.openxmlformats.org/drawingml/2006/main">
             <a:r>
-              <a:t>The public result is a reason to investigate a focused scope, not a forecast of the client’s complaint book.</a:t>
+              <a:t>The point is not to find the most impressive use case. It is to choose a use case whose risks can be bounded and whose decisions can be examined.</a:t>
             </a:r>
           </a:p>
           <a:p xmlns:a="http://schemas.openxmlformats.org/drawingml/2006/main">
@@ -1951,7 +2061,12 @@
           </a:p>
           <a:p xmlns:a="http://schemas.openxmlformats.org/drawingml/2006/main">
             <a:r>
-              <a:t>- Project repository: README.md and research/sector_research.md.</a:t>
+              <a:t>- Project repository: research/use_cases.md.</a:t>
+            </a:r>
+          </a:p>
+          <a:p xmlns:a="http://schemas.openxmlformats.org/drawingml/2006/main">
+            <a:r>
+              <a:t>- EU AI Act, Annex III: https://eur-lex.europa.eu/eli/reg/2024/1689/oj</a:t>
             </a:r>
           </a:p>
           <a:p xmlns:a="http://schemas.openxmlformats.org/drawingml/2006/main">
@@ -2026,7 +2141,7 @@
           <a:lstStyle xmlns:a="http://schemas.openxmlformats.org/drawingml/2006/main"/>
           <a:p xmlns:a="http://schemas.openxmlformats.org/drawingml/2006/main">
             <a:r>
-              <a:t>This public-data slide separates how often complaints occur from how often they end with monetary relief.</a:t>
+              <a:t>This chart explains how the public data supports a bounded initial test.</a:t>
             </a:r>
           </a:p>
           <a:p xmlns:a="http://schemas.openxmlformats.org/drawingml/2006/main">
@@ -2036,7 +2151,7 @@
           </a:p>
           <a:p xmlns:a="http://schemas.openxmlformats.org/drawingml/2006/main">
             <a:r>
-              <a:t>Checking and savings accounts and credit cards produce most of the complaint volume in this dataset. But monetary relief appears in 17.2% of credit-card complaints, compared with 3.0% for vehicle-lending complaints. That is a 5.7× difference.</a:t>
+              <a:t>In the public dataset, 5 of 64 issue categories account for 46.1% of complaints. That makes it possible to test a narrow, high-volume starting point instead of pretending the model can handle the entire taxonomy equally well.</a:t>
             </a:r>
           </a:p>
           <a:p xmlns:a="http://schemas.openxmlformats.org/drawingml/2006/main">
@@ -2046,7 +2161,7 @@
           </a:p>
           <a:p xmlns:a="http://schemas.openxmlformats.org/drawingml/2006/main">
             <a:r>
-              <a:t>The implication is that volume alone does not describe likely monetary relief. That relationship is a hypothesis to test, not a routing rule.</a:t>
+              <a:t>I would not assume that 46.1% applies to the client. Phase 0 must measure the client’s own concentration and decide which categories belong in the pilot.</a:t>
             </a:r>
           </a:p>
           <a:p xmlns:a="http://schemas.openxmlformats.org/drawingml/2006/main">
@@ -2056,7 +2171,7 @@
           </a:p>
           <a:p xmlns:a="http://schemas.openxmlformats.org/drawingml/2006/main">
             <a:r>
-              <a:t>This is a signal from public data, not a forecast for the client. The client’s own product mix, resolution costs, and escalation patterns must be measured during discovery and the pilot.</a:t>
+              <a:t>The public result is a reason to investigate a focused scope, not a forecast of the client’s complaint book.</a:t>
             </a:r>
           </a:p>
           <a:p xmlns:a="http://schemas.openxmlformats.org/drawingml/2006/main">
@@ -2081,7 +2196,7 @@
           </a:p>
           <a:p xmlns:a="http://schemas.openxmlformats.org/drawingml/2006/main">
             <a:r>
-              <a:t>- Project repository: research/sector_research.md and dashboard evidence.</a:t>
+              <a:t>- Project repository: README.md and research/sector_research.md.</a:t>
             </a:r>
           </a:p>
           <a:p xmlns:a="http://schemas.openxmlformats.org/drawingml/2006/main">
@@ -2156,7 +2271,7 @@
           <a:lstStyle xmlns:a="http://schemas.openxmlformats.org/drawingml/2006/main"/>
           <a:p xmlns:a="http://schemas.openxmlformats.org/drawingml/2006/main">
             <a:r>
-              <a:t>In the 60-case evaluation sample recorded in LangSmith, 52 complaints produced a proposal after passing the configured validation checks. Passing those checks does not prove that the proposed team was correct.</a:t>
+              <a:t>This public-data slide separates how often complaints occur from how often they end with monetary relief.</a:t>
             </a:r>
           </a:p>
           <a:p xmlns:a="http://schemas.openxmlformats.org/drawingml/2006/main">
@@ -2166,7 +2281,7 @@
           </a:p>
           <a:p xmlns:a="http://schemas.openxmlformats.org/drawingml/2006/main">
             <a:r>
-              <a:t>4 were flagged for human review because the model’s evidence quotation was not present verbatim in the complaint. Another 4 were flagged because confidence was below the threshold.</a:t>
+              <a:t>Checking and savings accounts and credit cards produce most of the complaint volume in this dataset. But monetary relief appears in 17.2% of credit-card complaints, compared with 3.0% for vehicle-lending complaints. That is a 5.7× difference.</a:t>
             </a:r>
           </a:p>
           <a:p xmlns:a="http://schemas.openxmlformats.org/drawingml/2006/main">
@@ -2176,7 +2291,7 @@
           </a:p>
           <a:p xmlns:a="http://schemas.openxmlformats.org/drawingml/2006/main">
             <a:r>
-              <a:t>Every case in the sample has a recorded outcome and a reason code. 0 cases lack a recorded outcome.</a:t>
+              <a:t>The implication is that volume alone does not describe likely monetary relief. That relationship is a hypothesis to test, not a routing rule.</a:t>
             </a:r>
           </a:p>
           <a:p xmlns:a="http://schemas.openxmlformats.org/drawingml/2006/main">
@@ -2186,7 +2301,7 @@
           </a:p>
           <a:p xmlns:a="http://schemas.openxmlformats.org/drawingml/2006/main">
             <a:r>
-              <a:t>This does not prove that every proposal was correct. It proves that proposals and stops can be traced and discussed.</a:t>
+              <a:t>This is a signal from public data, not a forecast for the client. The client’s own product mix, resolution costs, and escalation patterns must be measured during discovery and the pilot.</a:t>
             </a:r>
           </a:p>
           <a:p xmlns:a="http://schemas.openxmlformats.org/drawingml/2006/main">
@@ -2211,7 +2326,7 @@
           </a:p>
           <a:p xmlns:a="http://schemas.openxmlformats.org/drawingml/2006/main">
             <a:r>
-              <a:t>- Project repository: langsmith/experiment_summary.json.</a:t>
+              <a:t>- Project repository: research/sector_research.md and dashboard evidence.</a:t>
             </a:r>
           </a:p>
           <a:p xmlns:a="http://schemas.openxmlformats.org/drawingml/2006/main">
@@ -2284,7 +2399,7 @@
   </p:cSld>
   <p:clrMap bg1="lt1" tx1="dk1" bg2="lt2" tx2="dk2" accent1="accent1" accent2="accent2" accent3="accent3" accent4="accent4" accent5="accent5" accent6="accent6" hlink="hlink" folHlink="folHlink"/>
   <p:sldLayoutIdLst>
-    <p:sldLayoutId xmlns:r="http://schemas.openxmlformats.org/officeDocument/2006/relationships" id="2147483649" r:id="Rfe782b5d4bde487d"/>
+    <p:sldLayoutId xmlns:r="http://schemas.openxmlformats.org/officeDocument/2006/relationships" id="2147483649" r:id="Re9b0e0efd5d442d5"/>
   </p:sldLayoutIdLst>
   <p:hf sldNum="0" hdr="0" ftr="0" dt="0"/>
   <p:txStyles>
@@ -2879,9 +2994,10 @@
             <a:prstDash val="solid"/>
           </a:ln>
         </p:spPr>
-        <p:txBody xmlns:a="http://schemas.openxmlformats.org/drawingml/2006/main">
-          <a:bodyPr/>
-          <a:p/>
+        <p:txBody>
+          <a:bodyPr xmlns:a="http://schemas.openxmlformats.org/drawingml/2006/main"/>
+          <a:lstStyle xmlns:a="http://schemas.openxmlformats.org/drawingml/2006/main"/>
+          <a:p xmlns:a="http://schemas.openxmlformats.org/drawingml/2006/main"/>
         </p:txBody>
       </p:sp>
       <p:sp>
@@ -2912,9 +3028,10 @@
             </a:srgbClr>
           </a:solidFill>
         </p:spPr>
-        <p:txBody xmlns:a="http://schemas.openxmlformats.org/drawingml/2006/main">
-          <a:bodyPr/>
-          <a:p/>
+        <p:txBody>
+          <a:bodyPr xmlns:a="http://schemas.openxmlformats.org/drawingml/2006/main"/>
+          <a:lstStyle xmlns:a="http://schemas.openxmlformats.org/drawingml/2006/main"/>
+          <a:p xmlns:a="http://schemas.openxmlformats.org/drawingml/2006/main"/>
         </p:txBody>
       </p:sp>
       <p:sp>
@@ -3085,9 +3202,10 @@
             <a:prstDash val="solid"/>
           </a:ln>
         </p:spPr>
-        <p:txBody xmlns:a="http://schemas.openxmlformats.org/drawingml/2006/main">
-          <a:bodyPr/>
-          <a:p/>
+        <p:txBody>
+          <a:bodyPr xmlns:a="http://schemas.openxmlformats.org/drawingml/2006/main"/>
+          <a:lstStyle xmlns:a="http://schemas.openxmlformats.org/drawingml/2006/main"/>
+          <a:p xmlns:a="http://schemas.openxmlformats.org/drawingml/2006/main"/>
         </p:txBody>
       </p:sp>
       <p:sp>
@@ -3258,9 +3376,10 @@
             <a:srgbClr val="1D2A32"/>
           </a:solidFill>
         </p:spPr>
-        <p:txBody xmlns:a="http://schemas.openxmlformats.org/drawingml/2006/main">
-          <a:bodyPr/>
-          <a:p/>
+        <p:txBody>
+          <a:bodyPr xmlns:a="http://schemas.openxmlformats.org/drawingml/2006/main"/>
+          <a:lstStyle xmlns:a="http://schemas.openxmlformats.org/drawingml/2006/main"/>
+          <a:p xmlns:a="http://schemas.openxmlformats.org/drawingml/2006/main"/>
         </p:txBody>
       </p:sp>
       <p:sp>
@@ -3289,9 +3408,10 @@
             <a:srgbClr val="2A78D6"/>
           </a:solidFill>
         </p:spPr>
-        <p:txBody xmlns:a="http://schemas.openxmlformats.org/drawingml/2006/main">
-          <a:bodyPr/>
-          <a:p/>
+        <p:txBody>
+          <a:bodyPr xmlns:a="http://schemas.openxmlformats.org/drawingml/2006/main"/>
+          <a:lstStyle xmlns:a="http://schemas.openxmlformats.org/drawingml/2006/main"/>
+          <a:p xmlns:a="http://schemas.openxmlformats.org/drawingml/2006/main"/>
         </p:txBody>
       </p:sp>
       <p:sp>
@@ -3320,9 +3440,10 @@
             <a:srgbClr val="8FBFF0"/>
           </a:solidFill>
         </p:spPr>
-        <p:txBody xmlns:a="http://schemas.openxmlformats.org/drawingml/2006/main">
-          <a:bodyPr/>
-          <a:p/>
+        <p:txBody>
+          <a:bodyPr xmlns:a="http://schemas.openxmlformats.org/drawingml/2006/main"/>
+          <a:lstStyle xmlns:a="http://schemas.openxmlformats.org/drawingml/2006/main"/>
+          <a:p xmlns:a="http://schemas.openxmlformats.org/drawingml/2006/main"/>
         </p:txBody>
       </p:sp>
     </p:spTree>
@@ -3426,9 +3547,10 @@
             <a:srgbClr val="24343F"/>
           </a:solidFill>
         </p:spPr>
-        <p:txBody xmlns:a="http://schemas.openxmlformats.org/drawingml/2006/main">
-          <a:bodyPr/>
-          <a:p/>
+        <p:txBody>
+          <a:bodyPr xmlns:a="http://schemas.openxmlformats.org/drawingml/2006/main"/>
+          <a:lstStyle xmlns:a="http://schemas.openxmlformats.org/drawingml/2006/main"/>
+          <a:p xmlns:a="http://schemas.openxmlformats.org/drawingml/2006/main"/>
         </p:txBody>
       </p:sp>
       <p:pic>
@@ -3440,7 +3562,7 @@
           <p:nvPr/>
         </p:nvPicPr>
         <p:blipFill>
-          <a:blip xmlns:r="http://schemas.openxmlformats.org/officeDocument/2006/relationships" xmlns:a="http://schemas.openxmlformats.org/drawingml/2006/main" r:embed="R0e4194775f0846d6"/>
+          <a:blip xmlns:r="http://schemas.openxmlformats.org/officeDocument/2006/relationships" xmlns:a="http://schemas.openxmlformats.org/drawingml/2006/main" r:embed="Rc9eb5dcc5abf487f"/>
           <a:stretch xmlns:a="http://schemas.openxmlformats.org/drawingml/2006/main">
             <a:fillRect l="0" t="0" r="0" b="0"/>
           </a:stretch>
@@ -3527,9 +3649,10 @@
             <a:srgbClr val="EFF5F9"/>
           </a:solidFill>
         </p:spPr>
-        <p:txBody xmlns:a="http://schemas.openxmlformats.org/drawingml/2006/main">
-          <a:bodyPr/>
-          <a:p/>
+        <p:txBody>
+          <a:bodyPr xmlns:a="http://schemas.openxmlformats.org/drawingml/2006/main"/>
+          <a:lstStyle xmlns:a="http://schemas.openxmlformats.org/drawingml/2006/main"/>
+          <a:p xmlns:a="http://schemas.openxmlformats.org/drawingml/2006/main"/>
         </p:txBody>
       </p:sp>
       <p:sp>
@@ -3558,9 +3681,10 @@
             <a:srgbClr val="2A78D6"/>
           </a:solidFill>
         </p:spPr>
-        <p:txBody xmlns:a="http://schemas.openxmlformats.org/drawingml/2006/main">
-          <a:bodyPr/>
-          <a:p/>
+        <p:txBody>
+          <a:bodyPr xmlns:a="http://schemas.openxmlformats.org/drawingml/2006/main"/>
+          <a:lstStyle xmlns:a="http://schemas.openxmlformats.org/drawingml/2006/main"/>
+          <a:p xmlns:a="http://schemas.openxmlformats.org/drawingml/2006/main"/>
         </p:txBody>
       </p:sp>
       <p:sp>
@@ -3650,9 +3774,10 @@
             <a:prstDash val="solid"/>
           </a:ln>
         </p:spPr>
-        <p:txBody xmlns:a="http://schemas.openxmlformats.org/drawingml/2006/main">
-          <a:bodyPr/>
-          <a:p/>
+        <p:txBody>
+          <a:bodyPr xmlns:a="http://schemas.openxmlformats.org/drawingml/2006/main"/>
+          <a:lstStyle xmlns:a="http://schemas.openxmlformats.org/drawingml/2006/main"/>
+          <a:p xmlns:a="http://schemas.openxmlformats.org/drawingml/2006/main"/>
         </p:txBody>
       </p:sp>
       <p:sp>
@@ -4297,9 +4422,10 @@
             <a:srgbClr val="24343F"/>
           </a:solidFill>
         </p:spPr>
-        <p:txBody xmlns:a="http://schemas.openxmlformats.org/drawingml/2006/main">
-          <a:bodyPr/>
-          <a:p/>
+        <p:txBody>
+          <a:bodyPr xmlns:a="http://schemas.openxmlformats.org/drawingml/2006/main"/>
+          <a:lstStyle xmlns:a="http://schemas.openxmlformats.org/drawingml/2006/main"/>
+          <a:p xmlns:a="http://schemas.openxmlformats.org/drawingml/2006/main"/>
         </p:txBody>
       </p:sp>
       <p:sp>
@@ -4328,9 +4454,10 @@
             <a:srgbClr val="2A78D6"/>
           </a:solidFill>
         </p:spPr>
-        <p:txBody xmlns:a="http://schemas.openxmlformats.org/drawingml/2006/main">
-          <a:bodyPr/>
-          <a:p/>
+        <p:txBody>
+          <a:bodyPr xmlns:a="http://schemas.openxmlformats.org/drawingml/2006/main"/>
+          <a:lstStyle xmlns:a="http://schemas.openxmlformats.org/drawingml/2006/main"/>
+          <a:p xmlns:a="http://schemas.openxmlformats.org/drawingml/2006/main"/>
         </p:txBody>
       </p:sp>
       <p:sp>
@@ -4480,9 +4607,10 @@
             <a:srgbClr val="24343F"/>
           </a:solidFill>
         </p:spPr>
-        <p:txBody xmlns:a="http://schemas.openxmlformats.org/drawingml/2006/main">
-          <a:bodyPr/>
-          <a:p/>
+        <p:txBody>
+          <a:bodyPr xmlns:a="http://schemas.openxmlformats.org/drawingml/2006/main"/>
+          <a:lstStyle xmlns:a="http://schemas.openxmlformats.org/drawingml/2006/main"/>
+          <a:p xmlns:a="http://schemas.openxmlformats.org/drawingml/2006/main"/>
         </p:txBody>
       </p:sp>
       <p:pic>
@@ -4494,7 +4622,7 @@
           <p:nvPr/>
         </p:nvPicPr>
         <p:blipFill>
-          <a:blip xmlns:r="http://schemas.openxmlformats.org/officeDocument/2006/relationships" xmlns:a="http://schemas.openxmlformats.org/drawingml/2006/main" r:embed="Rf3668b642f14462f"/>
+          <a:blip xmlns:r="http://schemas.openxmlformats.org/officeDocument/2006/relationships" xmlns:a="http://schemas.openxmlformats.org/drawingml/2006/main" r:embed="R6d3366b995054f63"/>
           <a:stretch xmlns:a="http://schemas.openxmlformats.org/drawingml/2006/main">
             <a:fillRect l="0" t="0" r="0" b="0"/>
           </a:stretch>
@@ -4581,9 +4709,10 @@
             <a:srgbClr val="EFF5F9"/>
           </a:solidFill>
         </p:spPr>
-        <p:txBody xmlns:a="http://schemas.openxmlformats.org/drawingml/2006/main">
-          <a:bodyPr/>
-          <a:p/>
+        <p:txBody>
+          <a:bodyPr xmlns:a="http://schemas.openxmlformats.org/drawingml/2006/main"/>
+          <a:lstStyle xmlns:a="http://schemas.openxmlformats.org/drawingml/2006/main"/>
+          <a:p xmlns:a="http://schemas.openxmlformats.org/drawingml/2006/main"/>
         </p:txBody>
       </p:sp>
       <p:sp>
@@ -4612,9 +4741,10 @@
             <a:srgbClr val="2A78D6"/>
           </a:solidFill>
         </p:spPr>
-        <p:txBody xmlns:a="http://schemas.openxmlformats.org/drawingml/2006/main">
-          <a:bodyPr/>
-          <a:p/>
+        <p:txBody>
+          <a:bodyPr xmlns:a="http://schemas.openxmlformats.org/drawingml/2006/main"/>
+          <a:lstStyle xmlns:a="http://schemas.openxmlformats.org/drawingml/2006/main"/>
+          <a:p xmlns:a="http://schemas.openxmlformats.org/drawingml/2006/main"/>
         </p:txBody>
       </p:sp>
       <p:sp>
@@ -4693,9 +4823,10 @@
             <a:prstDash val="solid"/>
           </a:ln>
         </p:spPr>
-        <p:txBody xmlns:a="http://schemas.openxmlformats.org/drawingml/2006/main">
-          <a:bodyPr/>
-          <a:p/>
+        <p:txBody>
+          <a:bodyPr xmlns:a="http://schemas.openxmlformats.org/drawingml/2006/main"/>
+          <a:lstStyle xmlns:a="http://schemas.openxmlformats.org/drawingml/2006/main"/>
+          <a:p xmlns:a="http://schemas.openxmlformats.org/drawingml/2006/main"/>
         </p:txBody>
       </p:sp>
       <p:sp>
@@ -4740,7 +4871,7 @@
                   <a:srgbClr val="6B7C88"/>
                 </a:solidFill>
               </a:rPr>
-              <a:t>Source: Project evaluation vs CFPB-derived labels (gpt-4o, n=240); agreement, not accuracy.</a:t>
+              <a:t>Sources: Project evaluation vs CFPB-derived labels; OpenAI API pricing; agreement, not accuracy.</a:t>
             </a:r>
             <a:endParaRPr sz="850"/>
           </a:p>
@@ -4831,9 +4962,10 @@
             </a:outerShdw>
           </a:effectLst>
         </p:spPr>
-        <p:txBody xmlns:a="http://schemas.openxmlformats.org/drawingml/2006/main">
-          <a:bodyPr/>
-          <a:p/>
+        <p:txBody>
+          <a:bodyPr xmlns:a="http://schemas.openxmlformats.org/drawingml/2006/main"/>
+          <a:lstStyle xmlns:a="http://schemas.openxmlformats.org/drawingml/2006/main"/>
+          <a:p xmlns:a="http://schemas.openxmlformats.org/drawingml/2006/main"/>
         </p:txBody>
       </p:sp>
       <p:sp>
@@ -4862,9 +4994,10 @@
             <a:srgbClr val="24343F"/>
           </a:solidFill>
         </p:spPr>
-        <p:txBody xmlns:a="http://schemas.openxmlformats.org/drawingml/2006/main">
-          <a:bodyPr/>
-          <a:p/>
+        <p:txBody>
+          <a:bodyPr xmlns:a="http://schemas.openxmlformats.org/drawingml/2006/main"/>
+          <a:lstStyle xmlns:a="http://schemas.openxmlformats.org/drawingml/2006/main"/>
+          <a:p xmlns:a="http://schemas.openxmlformats.org/drawingml/2006/main"/>
         </p:txBody>
       </p:sp>
       <p:sp>
@@ -4978,7 +5111,7 @@
                 <a:ea typeface="Calibri"/>
                 <a:cs typeface="Calibri"/>
               </a:rPr>
-              <a:t>A model costing 17× more improved agreement by 4 percentage points</a:t>
+              <a:t>Paying 17× as much improved agreement by 3.7 percentage points</a:t>
             </a:r>
             <a:endParaRPr sz="1150"/>
           </a:p>
@@ -5044,9 +5177,10 @@
             </a:outerShdw>
           </a:effectLst>
         </p:spPr>
-        <p:txBody xmlns:a="http://schemas.openxmlformats.org/drawingml/2006/main">
-          <a:bodyPr/>
-          <a:p/>
+        <p:txBody>
+          <a:bodyPr xmlns:a="http://schemas.openxmlformats.org/drawingml/2006/main"/>
+          <a:lstStyle xmlns:a="http://schemas.openxmlformats.org/drawingml/2006/main"/>
+          <a:p xmlns:a="http://schemas.openxmlformats.org/drawingml/2006/main"/>
         </p:txBody>
       </p:sp>
       <p:sp>
@@ -5075,9 +5209,10 @@
             <a:srgbClr val="445A69"/>
           </a:solidFill>
         </p:spPr>
-        <p:txBody xmlns:a="http://schemas.openxmlformats.org/drawingml/2006/main">
-          <a:bodyPr/>
-          <a:p/>
+        <p:txBody>
+          <a:bodyPr xmlns:a="http://schemas.openxmlformats.org/drawingml/2006/main"/>
+          <a:lstStyle xmlns:a="http://schemas.openxmlformats.org/drawingml/2006/main"/>
+          <a:p xmlns:a="http://schemas.openxmlformats.org/drawingml/2006/main"/>
         </p:txBody>
       </p:sp>
       <p:sp>
@@ -5319,9 +5454,10 @@
             <a:srgbClr val="24343F"/>
           </a:solidFill>
         </p:spPr>
-        <p:txBody xmlns:a="http://schemas.openxmlformats.org/drawingml/2006/main">
-          <a:bodyPr/>
-          <a:p/>
+        <p:txBody>
+          <a:bodyPr xmlns:a="http://schemas.openxmlformats.org/drawingml/2006/main"/>
+          <a:lstStyle xmlns:a="http://schemas.openxmlformats.org/drawingml/2006/main"/>
+          <a:p xmlns:a="http://schemas.openxmlformats.org/drawingml/2006/main"/>
         </p:txBody>
       </p:sp>
       <p:pic>
@@ -5333,7 +5469,7 @@
           <p:nvPr/>
         </p:nvPicPr>
         <p:blipFill>
-          <a:blip xmlns:r="http://schemas.openxmlformats.org/officeDocument/2006/relationships" xmlns:a="http://schemas.openxmlformats.org/drawingml/2006/main" r:embed="R101fb8bc4b45479f"/>
+          <a:blip xmlns:r="http://schemas.openxmlformats.org/officeDocument/2006/relationships" xmlns:a="http://schemas.openxmlformats.org/drawingml/2006/main" r:embed="R48e87c1b6ebf4773"/>
           <a:stretch xmlns:a="http://schemas.openxmlformats.org/drawingml/2006/main">
             <a:fillRect l="0" t="0" r="0" b="0"/>
           </a:stretch>
@@ -5420,9 +5556,10 @@
             <a:srgbClr val="EFF5F9"/>
           </a:solidFill>
         </p:spPr>
-        <p:txBody xmlns:a="http://schemas.openxmlformats.org/drawingml/2006/main">
-          <a:bodyPr/>
-          <a:p/>
+        <p:txBody>
+          <a:bodyPr xmlns:a="http://schemas.openxmlformats.org/drawingml/2006/main"/>
+          <a:lstStyle xmlns:a="http://schemas.openxmlformats.org/drawingml/2006/main"/>
+          <a:p xmlns:a="http://schemas.openxmlformats.org/drawingml/2006/main"/>
         </p:txBody>
       </p:sp>
       <p:sp>
@@ -5451,9 +5588,10 @@
             <a:srgbClr val="2A78D6"/>
           </a:solidFill>
         </p:spPr>
-        <p:txBody xmlns:a="http://schemas.openxmlformats.org/drawingml/2006/main">
-          <a:bodyPr/>
-          <a:p/>
+        <p:txBody>
+          <a:bodyPr xmlns:a="http://schemas.openxmlformats.org/drawingml/2006/main"/>
+          <a:lstStyle xmlns:a="http://schemas.openxmlformats.org/drawingml/2006/main"/>
+          <a:p xmlns:a="http://schemas.openxmlformats.org/drawingml/2006/main"/>
         </p:txBody>
       </p:sp>
       <p:sp>
@@ -5543,9 +5681,10 @@
             <a:prstDash val="solid"/>
           </a:ln>
         </p:spPr>
-        <p:txBody xmlns:a="http://schemas.openxmlformats.org/drawingml/2006/main">
-          <a:bodyPr/>
-          <a:p/>
+        <p:txBody>
+          <a:bodyPr xmlns:a="http://schemas.openxmlformats.org/drawingml/2006/main"/>
+          <a:lstStyle xmlns:a="http://schemas.openxmlformats.org/drawingml/2006/main"/>
+          <a:p xmlns:a="http://schemas.openxmlformats.org/drawingml/2006/main"/>
         </p:txBody>
       </p:sp>
       <p:sp>
@@ -6165,9 +6304,10 @@
             <a:srgbClr val="24343F"/>
           </a:solidFill>
         </p:spPr>
-        <p:txBody xmlns:a="http://schemas.openxmlformats.org/drawingml/2006/main">
-          <a:bodyPr/>
-          <a:p/>
+        <p:txBody>
+          <a:bodyPr xmlns:a="http://schemas.openxmlformats.org/drawingml/2006/main"/>
+          <a:lstStyle xmlns:a="http://schemas.openxmlformats.org/drawingml/2006/main"/>
+          <a:p xmlns:a="http://schemas.openxmlformats.org/drawingml/2006/main"/>
         </p:txBody>
       </p:sp>
       <p:pic>
@@ -6179,7 +6319,7 @@
           <p:nvPr/>
         </p:nvPicPr>
         <p:blipFill>
-          <a:blip xmlns:r="http://schemas.openxmlformats.org/officeDocument/2006/relationships" xmlns:a="http://schemas.openxmlformats.org/drawingml/2006/main" r:embed="R755aed03094c477a"/>
+          <a:blip xmlns:r="http://schemas.openxmlformats.org/officeDocument/2006/relationships" xmlns:a="http://schemas.openxmlformats.org/drawingml/2006/main" r:embed="Re21402268c714a6a"/>
           <a:stretch xmlns:a="http://schemas.openxmlformats.org/drawingml/2006/main">
             <a:fillRect l="0" t="0" r="0" b="0"/>
           </a:stretch>
@@ -6266,9 +6406,10 @@
             <a:srgbClr val="EFF5F9"/>
           </a:solidFill>
         </p:spPr>
-        <p:txBody xmlns:a="http://schemas.openxmlformats.org/drawingml/2006/main">
-          <a:bodyPr/>
-          <a:p/>
+        <p:txBody>
+          <a:bodyPr xmlns:a="http://schemas.openxmlformats.org/drawingml/2006/main"/>
+          <a:lstStyle xmlns:a="http://schemas.openxmlformats.org/drawingml/2006/main"/>
+          <a:p xmlns:a="http://schemas.openxmlformats.org/drawingml/2006/main"/>
         </p:txBody>
       </p:sp>
       <p:sp>
@@ -6297,9 +6438,10 @@
             <a:srgbClr val="2A78D6"/>
           </a:solidFill>
         </p:spPr>
-        <p:txBody xmlns:a="http://schemas.openxmlformats.org/drawingml/2006/main">
-          <a:bodyPr/>
-          <a:p/>
+        <p:txBody>
+          <a:bodyPr xmlns:a="http://schemas.openxmlformats.org/drawingml/2006/main"/>
+          <a:lstStyle xmlns:a="http://schemas.openxmlformats.org/drawingml/2006/main"/>
+          <a:p xmlns:a="http://schemas.openxmlformats.org/drawingml/2006/main"/>
         </p:txBody>
       </p:sp>
       <p:sp>
@@ -6378,9 +6520,10 @@
             <a:prstDash val="solid"/>
           </a:ln>
         </p:spPr>
-        <p:txBody xmlns:a="http://schemas.openxmlformats.org/drawingml/2006/main">
-          <a:bodyPr/>
-          <a:p/>
+        <p:txBody>
+          <a:bodyPr xmlns:a="http://schemas.openxmlformats.org/drawingml/2006/main"/>
+          <a:lstStyle xmlns:a="http://schemas.openxmlformats.org/drawingml/2006/main"/>
+          <a:p xmlns:a="http://schemas.openxmlformats.org/drawingml/2006/main"/>
         </p:txBody>
       </p:sp>
       <p:sp>
@@ -7100,9 +7243,10 @@
             <a:srgbClr val="24343F"/>
           </a:solidFill>
         </p:spPr>
-        <p:txBody xmlns:a="http://schemas.openxmlformats.org/drawingml/2006/main">
-          <a:bodyPr/>
-          <a:p/>
+        <p:txBody>
+          <a:bodyPr xmlns:a="http://schemas.openxmlformats.org/drawingml/2006/main"/>
+          <a:lstStyle xmlns:a="http://schemas.openxmlformats.org/drawingml/2006/main"/>
+          <a:p xmlns:a="http://schemas.openxmlformats.org/drawingml/2006/main"/>
         </p:txBody>
       </p:sp>
       <p:pic>
@@ -7114,7 +7258,7 @@
           <p:nvPr/>
         </p:nvPicPr>
         <p:blipFill>
-          <a:blip xmlns:r="http://schemas.openxmlformats.org/officeDocument/2006/relationships" xmlns:a="http://schemas.openxmlformats.org/drawingml/2006/main" r:embed="Ree2210f3f94f46c4"/>
+          <a:blip xmlns:r="http://schemas.openxmlformats.org/officeDocument/2006/relationships" xmlns:a="http://schemas.openxmlformats.org/drawingml/2006/main" r:embed="R7cabf1e43f93427b"/>
           <a:stretch xmlns:a="http://schemas.openxmlformats.org/drawingml/2006/main">
             <a:fillRect l="0" t="0" r="0" b="0"/>
           </a:stretch>
@@ -7201,9 +7345,10 @@
             <a:srgbClr val="EFF5F9"/>
           </a:solidFill>
         </p:spPr>
-        <p:txBody xmlns:a="http://schemas.openxmlformats.org/drawingml/2006/main">
-          <a:bodyPr/>
-          <a:p/>
+        <p:txBody>
+          <a:bodyPr xmlns:a="http://schemas.openxmlformats.org/drawingml/2006/main"/>
+          <a:lstStyle xmlns:a="http://schemas.openxmlformats.org/drawingml/2006/main"/>
+          <a:p xmlns:a="http://schemas.openxmlformats.org/drawingml/2006/main"/>
         </p:txBody>
       </p:sp>
       <p:sp>
@@ -7232,9 +7377,10 @@
             <a:srgbClr val="2A78D6"/>
           </a:solidFill>
         </p:spPr>
-        <p:txBody xmlns:a="http://schemas.openxmlformats.org/drawingml/2006/main">
-          <a:bodyPr/>
-          <a:p/>
+        <p:txBody>
+          <a:bodyPr xmlns:a="http://schemas.openxmlformats.org/drawingml/2006/main"/>
+          <a:lstStyle xmlns:a="http://schemas.openxmlformats.org/drawingml/2006/main"/>
+          <a:p xmlns:a="http://schemas.openxmlformats.org/drawingml/2006/main"/>
         </p:txBody>
       </p:sp>
       <p:sp>
@@ -7313,9 +7459,10 @@
             <a:prstDash val="solid"/>
           </a:ln>
         </p:spPr>
-        <p:txBody xmlns:a="http://schemas.openxmlformats.org/drawingml/2006/main">
-          <a:bodyPr/>
-          <a:p/>
+        <p:txBody>
+          <a:bodyPr xmlns:a="http://schemas.openxmlformats.org/drawingml/2006/main"/>
+          <a:lstStyle xmlns:a="http://schemas.openxmlformats.org/drawingml/2006/main"/>
+          <a:p xmlns:a="http://schemas.openxmlformats.org/drawingml/2006/main"/>
         </p:txBody>
       </p:sp>
       <p:sp>
@@ -8430,9 +8577,10 @@
             <a:srgbClr val="24343F"/>
           </a:solidFill>
         </p:spPr>
-        <p:txBody xmlns:a="http://schemas.openxmlformats.org/drawingml/2006/main">
-          <a:bodyPr/>
-          <a:p/>
+        <p:txBody>
+          <a:bodyPr xmlns:a="http://schemas.openxmlformats.org/drawingml/2006/main"/>
+          <a:lstStyle xmlns:a="http://schemas.openxmlformats.org/drawingml/2006/main"/>
+          <a:p xmlns:a="http://schemas.openxmlformats.org/drawingml/2006/main"/>
         </p:txBody>
       </p:sp>
       <p:pic>
@@ -8444,7 +8592,7 @@
           <p:nvPr/>
         </p:nvPicPr>
         <p:blipFill>
-          <a:blip xmlns:r="http://schemas.openxmlformats.org/officeDocument/2006/relationships" xmlns:a="http://schemas.openxmlformats.org/drawingml/2006/main" r:embed="R90326f3209cd47fa"/>
+          <a:blip xmlns:r="http://schemas.openxmlformats.org/officeDocument/2006/relationships" xmlns:a="http://schemas.openxmlformats.org/drawingml/2006/main" r:embed="Ra182ad2b4ff249bc"/>
           <a:stretch xmlns:a="http://schemas.openxmlformats.org/drawingml/2006/main">
             <a:fillRect l="0" t="0" r="0" b="0"/>
           </a:stretch>
@@ -8531,9 +8679,10 @@
             <a:srgbClr val="EFF5F9"/>
           </a:solidFill>
         </p:spPr>
-        <p:txBody xmlns:a="http://schemas.openxmlformats.org/drawingml/2006/main">
-          <a:bodyPr/>
-          <a:p/>
+        <p:txBody>
+          <a:bodyPr xmlns:a="http://schemas.openxmlformats.org/drawingml/2006/main"/>
+          <a:lstStyle xmlns:a="http://schemas.openxmlformats.org/drawingml/2006/main"/>
+          <a:p xmlns:a="http://schemas.openxmlformats.org/drawingml/2006/main"/>
         </p:txBody>
       </p:sp>
       <p:sp>
@@ -8562,9 +8711,10 @@
             <a:srgbClr val="2A78D6"/>
           </a:solidFill>
         </p:spPr>
-        <p:txBody xmlns:a="http://schemas.openxmlformats.org/drawingml/2006/main">
-          <a:bodyPr/>
-          <a:p/>
+        <p:txBody>
+          <a:bodyPr xmlns:a="http://schemas.openxmlformats.org/drawingml/2006/main"/>
+          <a:lstStyle xmlns:a="http://schemas.openxmlformats.org/drawingml/2006/main"/>
+          <a:p xmlns:a="http://schemas.openxmlformats.org/drawingml/2006/main"/>
         </p:txBody>
       </p:sp>
       <p:sp>
@@ -8654,9 +8804,10 @@
             <a:prstDash val="solid"/>
           </a:ln>
         </p:spPr>
-        <p:txBody xmlns:a="http://schemas.openxmlformats.org/drawingml/2006/main">
-          <a:bodyPr/>
-          <a:p/>
+        <p:txBody>
+          <a:bodyPr xmlns:a="http://schemas.openxmlformats.org/drawingml/2006/main"/>
+          <a:lstStyle xmlns:a="http://schemas.openxmlformats.org/drawingml/2006/main"/>
+          <a:p xmlns:a="http://schemas.openxmlformats.org/drawingml/2006/main"/>
         </p:txBody>
       </p:sp>
       <p:sp>
@@ -8779,9 +8930,10 @@
             </a:outerShdw>
           </a:effectLst>
         </p:spPr>
-        <p:txBody xmlns:a="http://schemas.openxmlformats.org/drawingml/2006/main">
-          <a:bodyPr/>
-          <a:p/>
+        <p:txBody>
+          <a:bodyPr xmlns:a="http://schemas.openxmlformats.org/drawingml/2006/main"/>
+          <a:lstStyle xmlns:a="http://schemas.openxmlformats.org/drawingml/2006/main"/>
+          <a:p xmlns:a="http://schemas.openxmlformats.org/drawingml/2006/main"/>
         </p:txBody>
       </p:sp>
       <p:sp>
@@ -8955,9 +9107,10 @@
             </a:outerShdw>
           </a:effectLst>
         </p:spPr>
-        <p:txBody xmlns:a="http://schemas.openxmlformats.org/drawingml/2006/main">
-          <a:bodyPr/>
-          <a:p/>
+        <p:txBody>
+          <a:bodyPr xmlns:a="http://schemas.openxmlformats.org/drawingml/2006/main"/>
+          <a:lstStyle xmlns:a="http://schemas.openxmlformats.org/drawingml/2006/main"/>
+          <a:p xmlns:a="http://schemas.openxmlformats.org/drawingml/2006/main"/>
         </p:txBody>
       </p:sp>
       <p:sp>
@@ -9137,9 +9290,10 @@
             </a:outerShdw>
           </a:effectLst>
         </p:spPr>
-        <p:txBody xmlns:a="http://schemas.openxmlformats.org/drawingml/2006/main">
-          <a:bodyPr/>
-          <a:p/>
+        <p:txBody>
+          <a:bodyPr xmlns:a="http://schemas.openxmlformats.org/drawingml/2006/main"/>
+          <a:lstStyle xmlns:a="http://schemas.openxmlformats.org/drawingml/2006/main"/>
+          <a:p xmlns:a="http://schemas.openxmlformats.org/drawingml/2006/main"/>
         </p:txBody>
       </p:sp>
       <p:sp>
@@ -9306,9 +9460,10 @@
             <a:srgbClr val="EFF5F9"/>
           </a:solidFill>
         </p:spPr>
-        <p:txBody xmlns:a="http://schemas.openxmlformats.org/drawingml/2006/main">
-          <a:bodyPr/>
-          <a:p/>
+        <p:txBody>
+          <a:bodyPr xmlns:a="http://schemas.openxmlformats.org/drawingml/2006/main"/>
+          <a:lstStyle xmlns:a="http://schemas.openxmlformats.org/drawingml/2006/main"/>
+          <a:p xmlns:a="http://schemas.openxmlformats.org/drawingml/2006/main"/>
         </p:txBody>
       </p:sp>
       <p:sp>
@@ -9337,9 +9492,10 @@
             <a:srgbClr val="2A78D6"/>
           </a:solidFill>
         </p:spPr>
-        <p:txBody xmlns:a="http://schemas.openxmlformats.org/drawingml/2006/main">
-          <a:bodyPr/>
-          <a:p/>
+        <p:txBody>
+          <a:bodyPr xmlns:a="http://schemas.openxmlformats.org/drawingml/2006/main"/>
+          <a:lstStyle xmlns:a="http://schemas.openxmlformats.org/drawingml/2006/main"/>
+          <a:p xmlns:a="http://schemas.openxmlformats.org/drawingml/2006/main"/>
         </p:txBody>
       </p:sp>
       <p:sp>
@@ -9533,9 +9689,10 @@
             <a:srgbClr val="24343F"/>
           </a:solidFill>
         </p:spPr>
-        <p:txBody xmlns:a="http://schemas.openxmlformats.org/drawingml/2006/main">
-          <a:bodyPr/>
-          <a:p/>
+        <p:txBody>
+          <a:bodyPr xmlns:a="http://schemas.openxmlformats.org/drawingml/2006/main"/>
+          <a:lstStyle xmlns:a="http://schemas.openxmlformats.org/drawingml/2006/main"/>
+          <a:p xmlns:a="http://schemas.openxmlformats.org/drawingml/2006/main"/>
         </p:txBody>
       </p:sp>
       <p:pic>
@@ -9547,7 +9704,7 @@
           <p:nvPr/>
         </p:nvPicPr>
         <p:blipFill>
-          <a:blip xmlns:r="http://schemas.openxmlformats.org/officeDocument/2006/relationships" xmlns:a="http://schemas.openxmlformats.org/drawingml/2006/main" r:embed="R810e605741cb4c66"/>
+          <a:blip xmlns:r="http://schemas.openxmlformats.org/officeDocument/2006/relationships" xmlns:a="http://schemas.openxmlformats.org/drawingml/2006/main" r:embed="R2542d8ee38e84001"/>
           <a:stretch xmlns:a="http://schemas.openxmlformats.org/drawingml/2006/main">
             <a:fillRect l="0" t="0" r="0" b="0"/>
           </a:stretch>
@@ -9638,9 +9795,10 @@
             <a:prstDash val="solid"/>
           </a:ln>
         </p:spPr>
-        <p:txBody xmlns:a="http://schemas.openxmlformats.org/drawingml/2006/main">
-          <a:bodyPr/>
-          <a:p/>
+        <p:txBody>
+          <a:bodyPr xmlns:a="http://schemas.openxmlformats.org/drawingml/2006/main"/>
+          <a:lstStyle xmlns:a="http://schemas.openxmlformats.org/drawingml/2006/main"/>
+          <a:p xmlns:a="http://schemas.openxmlformats.org/drawingml/2006/main"/>
         </p:txBody>
       </p:sp>
       <p:sp>
@@ -9746,7 +9904,7 @@
           <p:nvPr/>
         </p:nvPicPr>
         <p:blipFill>
-          <a:blip xmlns:r="http://schemas.openxmlformats.org/officeDocument/2006/relationships" xmlns:a="http://schemas.openxmlformats.org/drawingml/2006/main" r:embed="R84080be2017a4bce"/>
+          <a:blip xmlns:r="http://schemas.openxmlformats.org/officeDocument/2006/relationships" xmlns:a="http://schemas.openxmlformats.org/drawingml/2006/main" r:embed="Rc2f1206326674045"/>
           <a:stretch xmlns:a="http://schemas.openxmlformats.org/drawingml/2006/main">
             <a:fillRect l="0" t="0" r="0" b="0"/>
           </a:stretch>
@@ -9794,9 +9952,10 @@
             </a:outerShdw>
           </a:effectLst>
         </p:spPr>
-        <p:txBody xmlns:a="http://schemas.openxmlformats.org/drawingml/2006/main">
-          <a:bodyPr/>
-          <a:p/>
+        <p:txBody>
+          <a:bodyPr xmlns:a="http://schemas.openxmlformats.org/drawingml/2006/main"/>
+          <a:lstStyle xmlns:a="http://schemas.openxmlformats.org/drawingml/2006/main"/>
+          <a:p xmlns:a="http://schemas.openxmlformats.org/drawingml/2006/main"/>
         </p:txBody>
       </p:sp>
       <p:sp>
@@ -10076,9 +10235,10 @@
             <a:srgbClr val="24343F"/>
           </a:solidFill>
         </p:spPr>
-        <p:txBody xmlns:a="http://schemas.openxmlformats.org/drawingml/2006/main">
-          <a:bodyPr/>
-          <a:p/>
+        <p:txBody>
+          <a:bodyPr xmlns:a="http://schemas.openxmlformats.org/drawingml/2006/main"/>
+          <a:lstStyle xmlns:a="http://schemas.openxmlformats.org/drawingml/2006/main"/>
+          <a:p xmlns:a="http://schemas.openxmlformats.org/drawingml/2006/main"/>
         </p:txBody>
       </p:sp>
       <p:pic>
@@ -10090,7 +10250,7 @@
           <p:nvPr/>
         </p:nvPicPr>
         <p:blipFill>
-          <a:blip xmlns:r="http://schemas.openxmlformats.org/officeDocument/2006/relationships" xmlns:a="http://schemas.openxmlformats.org/drawingml/2006/main" r:embed="Rbecef9ec958e49ea"/>
+          <a:blip xmlns:r="http://schemas.openxmlformats.org/officeDocument/2006/relationships" xmlns:a="http://schemas.openxmlformats.org/drawingml/2006/main" r:embed="R5c40637e669f4e2b"/>
           <a:stretch xmlns:a="http://schemas.openxmlformats.org/drawingml/2006/main">
             <a:fillRect l="0" t="0" r="0" b="0"/>
           </a:stretch>
@@ -10181,9 +10341,10 @@
             <a:prstDash val="solid"/>
           </a:ln>
         </p:spPr>
-        <p:txBody xmlns:a="http://schemas.openxmlformats.org/drawingml/2006/main">
-          <a:bodyPr/>
-          <a:p/>
+        <p:txBody>
+          <a:bodyPr xmlns:a="http://schemas.openxmlformats.org/drawingml/2006/main"/>
+          <a:lstStyle xmlns:a="http://schemas.openxmlformats.org/drawingml/2006/main"/>
+          <a:p xmlns:a="http://schemas.openxmlformats.org/drawingml/2006/main"/>
         </p:txBody>
       </p:sp>
       <p:sp>
@@ -10289,7 +10450,7 @@
           <p:nvPr/>
         </p:nvPicPr>
         <p:blipFill>
-          <a:blip xmlns:r="http://schemas.openxmlformats.org/officeDocument/2006/relationships" xmlns:a="http://schemas.openxmlformats.org/drawingml/2006/main" r:embed="Rb63f16244bda4fa8"/>
+          <a:blip xmlns:r="http://schemas.openxmlformats.org/officeDocument/2006/relationships" xmlns:a="http://schemas.openxmlformats.org/drawingml/2006/main" r:embed="R6c8422b1605d4a4e"/>
           <a:stretch xmlns:a="http://schemas.openxmlformats.org/drawingml/2006/main">
             <a:fillRect l="0" t="0" r="0" b="0"/>
           </a:stretch>
@@ -10313,7 +10474,7 @@
           <p:nvPr/>
         </p:nvPicPr>
         <p:blipFill>
-          <a:blip xmlns:r="http://schemas.openxmlformats.org/officeDocument/2006/relationships" xmlns:a="http://schemas.openxmlformats.org/drawingml/2006/main" r:embed="Rfb0a7e79a69d41d1"/>
+          <a:blip xmlns:r="http://schemas.openxmlformats.org/officeDocument/2006/relationships" xmlns:a="http://schemas.openxmlformats.org/drawingml/2006/main" r:embed="R2ceb03b144fc4639"/>
           <a:stretch xmlns:a="http://schemas.openxmlformats.org/drawingml/2006/main">
             <a:fillRect l="0" t="0" r="0" b="0"/>
           </a:stretch>
@@ -10446,9 +10607,10 @@
             <a:srgbClr val="2A78D6"/>
           </a:solidFill>
         </p:spPr>
-        <p:txBody xmlns:a="http://schemas.openxmlformats.org/drawingml/2006/main">
-          <a:bodyPr/>
-          <a:p/>
+        <p:txBody>
+          <a:bodyPr xmlns:a="http://schemas.openxmlformats.org/drawingml/2006/main"/>
+          <a:lstStyle xmlns:a="http://schemas.openxmlformats.org/drawingml/2006/main"/>
+          <a:p xmlns:a="http://schemas.openxmlformats.org/drawingml/2006/main"/>
         </p:txBody>
       </p:sp>
       <p:sp>
@@ -10477,9 +10639,10 @@
             <a:srgbClr val="2A78D6"/>
           </a:solidFill>
         </p:spPr>
-        <p:txBody xmlns:a="http://schemas.openxmlformats.org/drawingml/2006/main">
-          <a:bodyPr/>
-          <a:p/>
+        <p:txBody>
+          <a:bodyPr xmlns:a="http://schemas.openxmlformats.org/drawingml/2006/main"/>
+          <a:lstStyle xmlns:a="http://schemas.openxmlformats.org/drawingml/2006/main"/>
+          <a:p xmlns:a="http://schemas.openxmlformats.org/drawingml/2006/main"/>
         </p:txBody>
       </p:sp>
       <p:sp>
@@ -10508,9 +10671,10 @@
             <a:srgbClr val="2A78D6"/>
           </a:solidFill>
         </p:spPr>
-        <p:txBody xmlns:a="http://schemas.openxmlformats.org/drawingml/2006/main">
-          <a:bodyPr/>
-          <a:p/>
+        <p:txBody>
+          <a:bodyPr xmlns:a="http://schemas.openxmlformats.org/drawingml/2006/main"/>
+          <a:lstStyle xmlns:a="http://schemas.openxmlformats.org/drawingml/2006/main"/>
+          <a:p xmlns:a="http://schemas.openxmlformats.org/drawingml/2006/main"/>
         </p:txBody>
       </p:sp>
       <p:sp>
@@ -10539,9 +10703,10 @@
             <a:srgbClr val="2A78D6"/>
           </a:solidFill>
         </p:spPr>
-        <p:txBody xmlns:a="http://schemas.openxmlformats.org/drawingml/2006/main">
-          <a:bodyPr/>
-          <a:p/>
+        <p:txBody>
+          <a:bodyPr xmlns:a="http://schemas.openxmlformats.org/drawingml/2006/main"/>
+          <a:lstStyle xmlns:a="http://schemas.openxmlformats.org/drawingml/2006/main"/>
+          <a:p xmlns:a="http://schemas.openxmlformats.org/drawingml/2006/main"/>
         </p:txBody>
       </p:sp>
       <p:sp>
@@ -10570,9 +10735,10 @@
             <a:srgbClr val="2A78D6"/>
           </a:solidFill>
         </p:spPr>
-        <p:txBody xmlns:a="http://schemas.openxmlformats.org/drawingml/2006/main">
-          <a:bodyPr/>
-          <a:p/>
+        <p:txBody>
+          <a:bodyPr xmlns:a="http://schemas.openxmlformats.org/drawingml/2006/main"/>
+          <a:lstStyle xmlns:a="http://schemas.openxmlformats.org/drawingml/2006/main"/>
+          <a:p xmlns:a="http://schemas.openxmlformats.org/drawingml/2006/main"/>
         </p:txBody>
       </p:sp>
       <p:sp>
@@ -10601,9 +10767,10 @@
             <a:srgbClr val="2A78D6"/>
           </a:solidFill>
         </p:spPr>
-        <p:txBody xmlns:a="http://schemas.openxmlformats.org/drawingml/2006/main">
-          <a:bodyPr/>
-          <a:p/>
+        <p:txBody>
+          <a:bodyPr xmlns:a="http://schemas.openxmlformats.org/drawingml/2006/main"/>
+          <a:lstStyle xmlns:a="http://schemas.openxmlformats.org/drawingml/2006/main"/>
+          <a:p xmlns:a="http://schemas.openxmlformats.org/drawingml/2006/main"/>
         </p:txBody>
       </p:sp>
       <p:sp>
@@ -10632,9 +10799,10 @@
             <a:srgbClr val="2A78D6"/>
           </a:solidFill>
         </p:spPr>
-        <p:txBody xmlns:a="http://schemas.openxmlformats.org/drawingml/2006/main">
-          <a:bodyPr/>
-          <a:p/>
+        <p:txBody>
+          <a:bodyPr xmlns:a="http://schemas.openxmlformats.org/drawingml/2006/main"/>
+          <a:lstStyle xmlns:a="http://schemas.openxmlformats.org/drawingml/2006/main"/>
+          <a:p xmlns:a="http://schemas.openxmlformats.org/drawingml/2006/main"/>
         </p:txBody>
       </p:sp>
       <p:sp>
@@ -10663,9 +10831,10 @@
             <a:srgbClr val="2A78D6"/>
           </a:solidFill>
         </p:spPr>
-        <p:txBody xmlns:a="http://schemas.openxmlformats.org/drawingml/2006/main">
-          <a:bodyPr/>
-          <a:p/>
+        <p:txBody>
+          <a:bodyPr xmlns:a="http://schemas.openxmlformats.org/drawingml/2006/main"/>
+          <a:lstStyle xmlns:a="http://schemas.openxmlformats.org/drawingml/2006/main"/>
+          <a:p xmlns:a="http://schemas.openxmlformats.org/drawingml/2006/main"/>
         </p:txBody>
       </p:sp>
       <p:sp>
@@ -10694,9 +10863,10 @@
             <a:srgbClr val="2A78D6"/>
           </a:solidFill>
         </p:spPr>
-        <p:txBody xmlns:a="http://schemas.openxmlformats.org/drawingml/2006/main">
-          <a:bodyPr/>
-          <a:p/>
+        <p:txBody>
+          <a:bodyPr xmlns:a="http://schemas.openxmlformats.org/drawingml/2006/main"/>
+          <a:lstStyle xmlns:a="http://schemas.openxmlformats.org/drawingml/2006/main"/>
+          <a:p xmlns:a="http://schemas.openxmlformats.org/drawingml/2006/main"/>
         </p:txBody>
       </p:sp>
       <p:sp>
@@ -10725,9 +10895,10 @@
             <a:srgbClr val="2A78D6"/>
           </a:solidFill>
         </p:spPr>
-        <p:txBody xmlns:a="http://schemas.openxmlformats.org/drawingml/2006/main">
-          <a:bodyPr/>
-          <a:p/>
+        <p:txBody>
+          <a:bodyPr xmlns:a="http://schemas.openxmlformats.org/drawingml/2006/main"/>
+          <a:lstStyle xmlns:a="http://schemas.openxmlformats.org/drawingml/2006/main"/>
+          <a:p xmlns:a="http://schemas.openxmlformats.org/drawingml/2006/main"/>
         </p:txBody>
       </p:sp>
       <p:sp>
@@ -10756,9 +10927,10 @@
             <a:srgbClr val="2A78D6"/>
           </a:solidFill>
         </p:spPr>
-        <p:txBody xmlns:a="http://schemas.openxmlformats.org/drawingml/2006/main">
-          <a:bodyPr/>
-          <a:p/>
+        <p:txBody>
+          <a:bodyPr xmlns:a="http://schemas.openxmlformats.org/drawingml/2006/main"/>
+          <a:lstStyle xmlns:a="http://schemas.openxmlformats.org/drawingml/2006/main"/>
+          <a:p xmlns:a="http://schemas.openxmlformats.org/drawingml/2006/main"/>
         </p:txBody>
       </p:sp>
       <p:sp>
@@ -10787,9 +10959,10 @@
             <a:srgbClr val="2A78D6"/>
           </a:solidFill>
         </p:spPr>
-        <p:txBody xmlns:a="http://schemas.openxmlformats.org/drawingml/2006/main">
-          <a:bodyPr/>
-          <a:p/>
+        <p:txBody>
+          <a:bodyPr xmlns:a="http://schemas.openxmlformats.org/drawingml/2006/main"/>
+          <a:lstStyle xmlns:a="http://schemas.openxmlformats.org/drawingml/2006/main"/>
+          <a:p xmlns:a="http://schemas.openxmlformats.org/drawingml/2006/main"/>
         </p:txBody>
       </p:sp>
       <p:sp>
@@ -10818,9 +10991,10 @@
             <a:srgbClr val="2A78D6"/>
           </a:solidFill>
         </p:spPr>
-        <p:txBody xmlns:a="http://schemas.openxmlformats.org/drawingml/2006/main">
-          <a:bodyPr/>
-          <a:p/>
+        <p:txBody>
+          <a:bodyPr xmlns:a="http://schemas.openxmlformats.org/drawingml/2006/main"/>
+          <a:lstStyle xmlns:a="http://schemas.openxmlformats.org/drawingml/2006/main"/>
+          <a:p xmlns:a="http://schemas.openxmlformats.org/drawingml/2006/main"/>
         </p:txBody>
       </p:sp>
       <p:sp>
@@ -10849,9 +11023,10 @@
             <a:srgbClr val="2A78D6"/>
           </a:solidFill>
         </p:spPr>
-        <p:txBody xmlns:a="http://schemas.openxmlformats.org/drawingml/2006/main">
-          <a:bodyPr/>
-          <a:p/>
+        <p:txBody>
+          <a:bodyPr xmlns:a="http://schemas.openxmlformats.org/drawingml/2006/main"/>
+          <a:lstStyle xmlns:a="http://schemas.openxmlformats.org/drawingml/2006/main"/>
+          <a:p xmlns:a="http://schemas.openxmlformats.org/drawingml/2006/main"/>
         </p:txBody>
       </p:sp>
       <p:sp>
@@ -10880,9 +11055,10 @@
             <a:srgbClr val="2A78D6"/>
           </a:solidFill>
         </p:spPr>
-        <p:txBody xmlns:a="http://schemas.openxmlformats.org/drawingml/2006/main">
-          <a:bodyPr/>
-          <a:p/>
+        <p:txBody>
+          <a:bodyPr xmlns:a="http://schemas.openxmlformats.org/drawingml/2006/main"/>
+          <a:lstStyle xmlns:a="http://schemas.openxmlformats.org/drawingml/2006/main"/>
+          <a:p xmlns:a="http://schemas.openxmlformats.org/drawingml/2006/main"/>
         </p:txBody>
       </p:sp>
       <p:sp>
@@ -10911,9 +11087,10 @@
             <a:srgbClr val="2A78D6"/>
           </a:solidFill>
         </p:spPr>
-        <p:txBody xmlns:a="http://schemas.openxmlformats.org/drawingml/2006/main">
-          <a:bodyPr/>
-          <a:p/>
+        <p:txBody>
+          <a:bodyPr xmlns:a="http://schemas.openxmlformats.org/drawingml/2006/main"/>
+          <a:lstStyle xmlns:a="http://schemas.openxmlformats.org/drawingml/2006/main"/>
+          <a:p xmlns:a="http://schemas.openxmlformats.org/drawingml/2006/main"/>
         </p:txBody>
       </p:sp>
       <p:sp>
@@ -10942,9 +11119,10 @@
             <a:srgbClr val="2A78D6"/>
           </a:solidFill>
         </p:spPr>
-        <p:txBody xmlns:a="http://schemas.openxmlformats.org/drawingml/2006/main">
-          <a:bodyPr/>
-          <a:p/>
+        <p:txBody>
+          <a:bodyPr xmlns:a="http://schemas.openxmlformats.org/drawingml/2006/main"/>
+          <a:lstStyle xmlns:a="http://schemas.openxmlformats.org/drawingml/2006/main"/>
+          <a:p xmlns:a="http://schemas.openxmlformats.org/drawingml/2006/main"/>
         </p:txBody>
       </p:sp>
       <p:sp>
@@ -10973,9 +11151,10 @@
             <a:srgbClr val="2A78D6"/>
           </a:solidFill>
         </p:spPr>
-        <p:txBody xmlns:a="http://schemas.openxmlformats.org/drawingml/2006/main">
-          <a:bodyPr/>
-          <a:p/>
+        <p:txBody>
+          <a:bodyPr xmlns:a="http://schemas.openxmlformats.org/drawingml/2006/main"/>
+          <a:lstStyle xmlns:a="http://schemas.openxmlformats.org/drawingml/2006/main"/>
+          <a:p xmlns:a="http://schemas.openxmlformats.org/drawingml/2006/main"/>
         </p:txBody>
       </p:sp>
       <p:sp>
@@ -11004,9 +11183,10 @@
             <a:srgbClr val="2A78D6"/>
           </a:solidFill>
         </p:spPr>
-        <p:txBody xmlns:a="http://schemas.openxmlformats.org/drawingml/2006/main">
-          <a:bodyPr/>
-          <a:p/>
+        <p:txBody>
+          <a:bodyPr xmlns:a="http://schemas.openxmlformats.org/drawingml/2006/main"/>
+          <a:lstStyle xmlns:a="http://schemas.openxmlformats.org/drawingml/2006/main"/>
+          <a:p xmlns:a="http://schemas.openxmlformats.org/drawingml/2006/main"/>
         </p:txBody>
       </p:sp>
       <p:sp>
@@ -11035,9 +11215,10 @@
             <a:srgbClr val="2A78D6"/>
           </a:solidFill>
         </p:spPr>
-        <p:txBody xmlns:a="http://schemas.openxmlformats.org/drawingml/2006/main">
-          <a:bodyPr/>
-          <a:p/>
+        <p:txBody>
+          <a:bodyPr xmlns:a="http://schemas.openxmlformats.org/drawingml/2006/main"/>
+          <a:lstStyle xmlns:a="http://schemas.openxmlformats.org/drawingml/2006/main"/>
+          <a:p xmlns:a="http://schemas.openxmlformats.org/drawingml/2006/main"/>
         </p:txBody>
       </p:sp>
       <p:sp>
@@ -11066,9 +11247,10 @@
             <a:srgbClr val="2A78D6"/>
           </a:solidFill>
         </p:spPr>
-        <p:txBody xmlns:a="http://schemas.openxmlformats.org/drawingml/2006/main">
-          <a:bodyPr/>
-          <a:p/>
+        <p:txBody>
+          <a:bodyPr xmlns:a="http://schemas.openxmlformats.org/drawingml/2006/main"/>
+          <a:lstStyle xmlns:a="http://schemas.openxmlformats.org/drawingml/2006/main"/>
+          <a:p xmlns:a="http://schemas.openxmlformats.org/drawingml/2006/main"/>
         </p:txBody>
       </p:sp>
       <p:sp>
@@ -11097,9 +11279,10 @@
             <a:srgbClr val="2A78D6"/>
           </a:solidFill>
         </p:spPr>
-        <p:txBody xmlns:a="http://schemas.openxmlformats.org/drawingml/2006/main">
-          <a:bodyPr/>
-          <a:p/>
+        <p:txBody>
+          <a:bodyPr xmlns:a="http://schemas.openxmlformats.org/drawingml/2006/main"/>
+          <a:lstStyle xmlns:a="http://schemas.openxmlformats.org/drawingml/2006/main"/>
+          <a:p xmlns:a="http://schemas.openxmlformats.org/drawingml/2006/main"/>
         </p:txBody>
       </p:sp>
       <p:sp>
@@ -11128,9 +11311,10 @@
             <a:srgbClr val="2A78D6"/>
           </a:solidFill>
         </p:spPr>
-        <p:txBody xmlns:a="http://schemas.openxmlformats.org/drawingml/2006/main">
-          <a:bodyPr/>
-          <a:p/>
+        <p:txBody>
+          <a:bodyPr xmlns:a="http://schemas.openxmlformats.org/drawingml/2006/main"/>
+          <a:lstStyle xmlns:a="http://schemas.openxmlformats.org/drawingml/2006/main"/>
+          <a:p xmlns:a="http://schemas.openxmlformats.org/drawingml/2006/main"/>
         </p:txBody>
       </p:sp>
       <p:sp>
@@ -11159,9 +11343,10 @@
             <a:srgbClr val="2A78D6"/>
           </a:solidFill>
         </p:spPr>
-        <p:txBody xmlns:a="http://schemas.openxmlformats.org/drawingml/2006/main">
-          <a:bodyPr/>
-          <a:p/>
+        <p:txBody>
+          <a:bodyPr xmlns:a="http://schemas.openxmlformats.org/drawingml/2006/main"/>
+          <a:lstStyle xmlns:a="http://schemas.openxmlformats.org/drawingml/2006/main"/>
+          <a:p xmlns:a="http://schemas.openxmlformats.org/drawingml/2006/main"/>
         </p:txBody>
       </p:sp>
       <p:sp>
@@ -11190,9 +11375,10 @@
             <a:srgbClr val="2A78D6"/>
           </a:solidFill>
         </p:spPr>
-        <p:txBody xmlns:a="http://schemas.openxmlformats.org/drawingml/2006/main">
-          <a:bodyPr/>
-          <a:p/>
+        <p:txBody>
+          <a:bodyPr xmlns:a="http://schemas.openxmlformats.org/drawingml/2006/main"/>
+          <a:lstStyle xmlns:a="http://schemas.openxmlformats.org/drawingml/2006/main"/>
+          <a:p xmlns:a="http://schemas.openxmlformats.org/drawingml/2006/main"/>
         </p:txBody>
       </p:sp>
       <p:sp>
@@ -11221,9 +11407,10 @@
             <a:srgbClr val="2A78D6"/>
           </a:solidFill>
         </p:spPr>
-        <p:txBody xmlns:a="http://schemas.openxmlformats.org/drawingml/2006/main">
-          <a:bodyPr/>
-          <a:p/>
+        <p:txBody>
+          <a:bodyPr xmlns:a="http://schemas.openxmlformats.org/drawingml/2006/main"/>
+          <a:lstStyle xmlns:a="http://schemas.openxmlformats.org/drawingml/2006/main"/>
+          <a:p xmlns:a="http://schemas.openxmlformats.org/drawingml/2006/main"/>
         </p:txBody>
       </p:sp>
       <p:sp>
@@ -11252,9 +11439,10 @@
             <a:srgbClr val="2A78D6"/>
           </a:solidFill>
         </p:spPr>
-        <p:txBody xmlns:a="http://schemas.openxmlformats.org/drawingml/2006/main">
-          <a:bodyPr/>
-          <a:p/>
+        <p:txBody>
+          <a:bodyPr xmlns:a="http://schemas.openxmlformats.org/drawingml/2006/main"/>
+          <a:lstStyle xmlns:a="http://schemas.openxmlformats.org/drawingml/2006/main"/>
+          <a:p xmlns:a="http://schemas.openxmlformats.org/drawingml/2006/main"/>
         </p:txBody>
       </p:sp>
       <p:sp>
@@ -11283,9 +11471,10 @@
             <a:srgbClr val="2A78D6"/>
           </a:solidFill>
         </p:spPr>
-        <p:txBody xmlns:a="http://schemas.openxmlformats.org/drawingml/2006/main">
-          <a:bodyPr/>
-          <a:p/>
+        <p:txBody>
+          <a:bodyPr xmlns:a="http://schemas.openxmlformats.org/drawingml/2006/main"/>
+          <a:lstStyle xmlns:a="http://schemas.openxmlformats.org/drawingml/2006/main"/>
+          <a:p xmlns:a="http://schemas.openxmlformats.org/drawingml/2006/main"/>
         </p:txBody>
       </p:sp>
       <p:sp>
@@ -11314,9 +11503,10 @@
             <a:srgbClr val="2A78D6"/>
           </a:solidFill>
         </p:spPr>
-        <p:txBody xmlns:a="http://schemas.openxmlformats.org/drawingml/2006/main">
-          <a:bodyPr/>
-          <a:p/>
+        <p:txBody>
+          <a:bodyPr xmlns:a="http://schemas.openxmlformats.org/drawingml/2006/main"/>
+          <a:lstStyle xmlns:a="http://schemas.openxmlformats.org/drawingml/2006/main"/>
+          <a:p xmlns:a="http://schemas.openxmlformats.org/drawingml/2006/main"/>
         </p:txBody>
       </p:sp>
       <p:sp>
@@ -11345,9 +11535,10 @@
             <a:srgbClr val="2A78D6"/>
           </a:solidFill>
         </p:spPr>
-        <p:txBody xmlns:a="http://schemas.openxmlformats.org/drawingml/2006/main">
-          <a:bodyPr/>
-          <a:p/>
+        <p:txBody>
+          <a:bodyPr xmlns:a="http://schemas.openxmlformats.org/drawingml/2006/main"/>
+          <a:lstStyle xmlns:a="http://schemas.openxmlformats.org/drawingml/2006/main"/>
+          <a:p xmlns:a="http://schemas.openxmlformats.org/drawingml/2006/main"/>
         </p:txBody>
       </p:sp>
       <p:sp>
@@ -11376,9 +11567,10 @@
             <a:srgbClr val="2A78D6"/>
           </a:solidFill>
         </p:spPr>
-        <p:txBody xmlns:a="http://schemas.openxmlformats.org/drawingml/2006/main">
-          <a:bodyPr/>
-          <a:p/>
+        <p:txBody>
+          <a:bodyPr xmlns:a="http://schemas.openxmlformats.org/drawingml/2006/main"/>
+          <a:lstStyle xmlns:a="http://schemas.openxmlformats.org/drawingml/2006/main"/>
+          <a:p xmlns:a="http://schemas.openxmlformats.org/drawingml/2006/main"/>
         </p:txBody>
       </p:sp>
       <p:sp>
@@ -11407,9 +11599,10 @@
             <a:srgbClr val="2A78D6"/>
           </a:solidFill>
         </p:spPr>
-        <p:txBody xmlns:a="http://schemas.openxmlformats.org/drawingml/2006/main">
-          <a:bodyPr/>
-          <a:p/>
+        <p:txBody>
+          <a:bodyPr xmlns:a="http://schemas.openxmlformats.org/drawingml/2006/main"/>
+          <a:lstStyle xmlns:a="http://schemas.openxmlformats.org/drawingml/2006/main"/>
+          <a:p xmlns:a="http://schemas.openxmlformats.org/drawingml/2006/main"/>
         </p:txBody>
       </p:sp>
       <p:sp>
@@ -11438,9 +11631,10 @@
             <a:srgbClr val="2A78D6"/>
           </a:solidFill>
         </p:spPr>
-        <p:txBody xmlns:a="http://schemas.openxmlformats.org/drawingml/2006/main">
-          <a:bodyPr/>
-          <a:p/>
+        <p:txBody>
+          <a:bodyPr xmlns:a="http://schemas.openxmlformats.org/drawingml/2006/main"/>
+          <a:lstStyle xmlns:a="http://schemas.openxmlformats.org/drawingml/2006/main"/>
+          <a:p xmlns:a="http://schemas.openxmlformats.org/drawingml/2006/main"/>
         </p:txBody>
       </p:sp>
       <p:sp>
@@ -11469,9 +11663,10 @@
             <a:srgbClr val="2A78D6"/>
           </a:solidFill>
         </p:spPr>
-        <p:txBody xmlns:a="http://schemas.openxmlformats.org/drawingml/2006/main">
-          <a:bodyPr/>
-          <a:p/>
+        <p:txBody>
+          <a:bodyPr xmlns:a="http://schemas.openxmlformats.org/drawingml/2006/main"/>
+          <a:lstStyle xmlns:a="http://schemas.openxmlformats.org/drawingml/2006/main"/>
+          <a:p xmlns:a="http://schemas.openxmlformats.org/drawingml/2006/main"/>
         </p:txBody>
       </p:sp>
       <p:sp>
@@ -11500,9 +11695,10 @@
             <a:srgbClr val="2A78D6"/>
           </a:solidFill>
         </p:spPr>
-        <p:txBody xmlns:a="http://schemas.openxmlformats.org/drawingml/2006/main">
-          <a:bodyPr/>
-          <a:p/>
+        <p:txBody>
+          <a:bodyPr xmlns:a="http://schemas.openxmlformats.org/drawingml/2006/main"/>
+          <a:lstStyle xmlns:a="http://schemas.openxmlformats.org/drawingml/2006/main"/>
+          <a:p xmlns:a="http://schemas.openxmlformats.org/drawingml/2006/main"/>
         </p:txBody>
       </p:sp>
       <p:sp>
@@ -11531,9 +11727,10 @@
             <a:srgbClr val="2A78D6"/>
           </a:solidFill>
         </p:spPr>
-        <p:txBody xmlns:a="http://schemas.openxmlformats.org/drawingml/2006/main">
-          <a:bodyPr/>
-          <a:p/>
+        <p:txBody>
+          <a:bodyPr xmlns:a="http://schemas.openxmlformats.org/drawingml/2006/main"/>
+          <a:lstStyle xmlns:a="http://schemas.openxmlformats.org/drawingml/2006/main"/>
+          <a:p xmlns:a="http://schemas.openxmlformats.org/drawingml/2006/main"/>
         </p:txBody>
       </p:sp>
       <p:sp>
@@ -11562,9 +11759,10 @@
             <a:srgbClr val="2A78D6"/>
           </a:solidFill>
         </p:spPr>
-        <p:txBody xmlns:a="http://schemas.openxmlformats.org/drawingml/2006/main">
-          <a:bodyPr/>
-          <a:p/>
+        <p:txBody>
+          <a:bodyPr xmlns:a="http://schemas.openxmlformats.org/drawingml/2006/main"/>
+          <a:lstStyle xmlns:a="http://schemas.openxmlformats.org/drawingml/2006/main"/>
+          <a:p xmlns:a="http://schemas.openxmlformats.org/drawingml/2006/main"/>
         </p:txBody>
       </p:sp>
       <p:sp>
@@ -11593,9 +11791,10 @@
             <a:srgbClr val="2A78D6"/>
           </a:solidFill>
         </p:spPr>
-        <p:txBody xmlns:a="http://schemas.openxmlformats.org/drawingml/2006/main">
-          <a:bodyPr/>
-          <a:p/>
+        <p:txBody>
+          <a:bodyPr xmlns:a="http://schemas.openxmlformats.org/drawingml/2006/main"/>
+          <a:lstStyle xmlns:a="http://schemas.openxmlformats.org/drawingml/2006/main"/>
+          <a:p xmlns:a="http://schemas.openxmlformats.org/drawingml/2006/main"/>
         </p:txBody>
       </p:sp>
       <p:sp>
@@ -11624,9 +11823,10 @@
             <a:srgbClr val="2A78D6"/>
           </a:solidFill>
         </p:spPr>
-        <p:txBody xmlns:a="http://schemas.openxmlformats.org/drawingml/2006/main">
-          <a:bodyPr/>
-          <a:p/>
+        <p:txBody>
+          <a:bodyPr xmlns:a="http://schemas.openxmlformats.org/drawingml/2006/main"/>
+          <a:lstStyle xmlns:a="http://schemas.openxmlformats.org/drawingml/2006/main"/>
+          <a:p xmlns:a="http://schemas.openxmlformats.org/drawingml/2006/main"/>
         </p:txBody>
       </p:sp>
       <p:sp>
@@ -11655,9 +11855,10 @@
             <a:srgbClr val="2A78D6"/>
           </a:solidFill>
         </p:spPr>
-        <p:txBody xmlns:a="http://schemas.openxmlformats.org/drawingml/2006/main">
-          <a:bodyPr/>
-          <a:p/>
+        <p:txBody>
+          <a:bodyPr xmlns:a="http://schemas.openxmlformats.org/drawingml/2006/main"/>
+          <a:lstStyle xmlns:a="http://schemas.openxmlformats.org/drawingml/2006/main"/>
+          <a:p xmlns:a="http://schemas.openxmlformats.org/drawingml/2006/main"/>
         </p:txBody>
       </p:sp>
       <p:sp>
@@ -11686,9 +11887,10 @@
             <a:srgbClr val="2A78D6"/>
           </a:solidFill>
         </p:spPr>
-        <p:txBody xmlns:a="http://schemas.openxmlformats.org/drawingml/2006/main">
-          <a:bodyPr/>
-          <a:p/>
+        <p:txBody>
+          <a:bodyPr xmlns:a="http://schemas.openxmlformats.org/drawingml/2006/main"/>
+          <a:lstStyle xmlns:a="http://schemas.openxmlformats.org/drawingml/2006/main"/>
+          <a:p xmlns:a="http://schemas.openxmlformats.org/drawingml/2006/main"/>
         </p:txBody>
       </p:sp>
       <p:sp>
@@ -11717,9 +11919,10 @@
             <a:srgbClr val="2A78D6"/>
           </a:solidFill>
         </p:spPr>
-        <p:txBody xmlns:a="http://schemas.openxmlformats.org/drawingml/2006/main">
-          <a:bodyPr/>
-          <a:p/>
+        <p:txBody>
+          <a:bodyPr xmlns:a="http://schemas.openxmlformats.org/drawingml/2006/main"/>
+          <a:lstStyle xmlns:a="http://schemas.openxmlformats.org/drawingml/2006/main"/>
+          <a:p xmlns:a="http://schemas.openxmlformats.org/drawingml/2006/main"/>
         </p:txBody>
       </p:sp>
       <p:sp>
@@ -11748,9 +11951,10 @@
             <a:srgbClr val="2A78D6"/>
           </a:solidFill>
         </p:spPr>
-        <p:txBody xmlns:a="http://schemas.openxmlformats.org/drawingml/2006/main">
-          <a:bodyPr/>
-          <a:p/>
+        <p:txBody>
+          <a:bodyPr xmlns:a="http://schemas.openxmlformats.org/drawingml/2006/main"/>
+          <a:lstStyle xmlns:a="http://schemas.openxmlformats.org/drawingml/2006/main"/>
+          <a:p xmlns:a="http://schemas.openxmlformats.org/drawingml/2006/main"/>
         </p:txBody>
       </p:sp>
       <p:sp>
@@ -11779,9 +11983,10 @@
             <a:srgbClr val="2A78D6"/>
           </a:solidFill>
         </p:spPr>
-        <p:txBody xmlns:a="http://schemas.openxmlformats.org/drawingml/2006/main">
-          <a:bodyPr/>
-          <a:p/>
+        <p:txBody>
+          <a:bodyPr xmlns:a="http://schemas.openxmlformats.org/drawingml/2006/main"/>
+          <a:lstStyle xmlns:a="http://schemas.openxmlformats.org/drawingml/2006/main"/>
+          <a:p xmlns:a="http://schemas.openxmlformats.org/drawingml/2006/main"/>
         </p:txBody>
       </p:sp>
       <p:sp>
@@ -11810,9 +12015,10 @@
             <a:srgbClr val="2A78D6"/>
           </a:solidFill>
         </p:spPr>
-        <p:txBody xmlns:a="http://schemas.openxmlformats.org/drawingml/2006/main">
-          <a:bodyPr/>
-          <a:p/>
+        <p:txBody>
+          <a:bodyPr xmlns:a="http://schemas.openxmlformats.org/drawingml/2006/main"/>
+          <a:lstStyle xmlns:a="http://schemas.openxmlformats.org/drawingml/2006/main"/>
+          <a:p xmlns:a="http://schemas.openxmlformats.org/drawingml/2006/main"/>
         </p:txBody>
       </p:sp>
       <p:sp>
@@ -11841,9 +12047,10 @@
             <a:srgbClr val="2A78D6"/>
           </a:solidFill>
         </p:spPr>
-        <p:txBody xmlns:a="http://schemas.openxmlformats.org/drawingml/2006/main">
-          <a:bodyPr/>
-          <a:p/>
+        <p:txBody>
+          <a:bodyPr xmlns:a="http://schemas.openxmlformats.org/drawingml/2006/main"/>
+          <a:lstStyle xmlns:a="http://schemas.openxmlformats.org/drawingml/2006/main"/>
+          <a:p xmlns:a="http://schemas.openxmlformats.org/drawingml/2006/main"/>
         </p:txBody>
       </p:sp>
       <p:sp>
@@ -11872,9 +12079,10 @@
             <a:srgbClr val="2A78D6"/>
           </a:solidFill>
         </p:spPr>
-        <p:txBody xmlns:a="http://schemas.openxmlformats.org/drawingml/2006/main">
-          <a:bodyPr/>
-          <a:p/>
+        <p:txBody>
+          <a:bodyPr xmlns:a="http://schemas.openxmlformats.org/drawingml/2006/main"/>
+          <a:lstStyle xmlns:a="http://schemas.openxmlformats.org/drawingml/2006/main"/>
+          <a:p xmlns:a="http://schemas.openxmlformats.org/drawingml/2006/main"/>
         </p:txBody>
       </p:sp>
       <p:sp>
@@ -11903,9 +12111,10 @@
             <a:srgbClr val="2A78D6"/>
           </a:solidFill>
         </p:spPr>
-        <p:txBody xmlns:a="http://schemas.openxmlformats.org/drawingml/2006/main">
-          <a:bodyPr/>
-          <a:p/>
+        <p:txBody>
+          <a:bodyPr xmlns:a="http://schemas.openxmlformats.org/drawingml/2006/main"/>
+          <a:lstStyle xmlns:a="http://schemas.openxmlformats.org/drawingml/2006/main"/>
+          <a:p xmlns:a="http://schemas.openxmlformats.org/drawingml/2006/main"/>
         </p:txBody>
       </p:sp>
       <p:sp>
@@ -11934,9 +12143,10 @@
             <a:srgbClr val="2A78D6"/>
           </a:solidFill>
         </p:spPr>
-        <p:txBody xmlns:a="http://schemas.openxmlformats.org/drawingml/2006/main">
-          <a:bodyPr/>
-          <a:p/>
+        <p:txBody>
+          <a:bodyPr xmlns:a="http://schemas.openxmlformats.org/drawingml/2006/main"/>
+          <a:lstStyle xmlns:a="http://schemas.openxmlformats.org/drawingml/2006/main"/>
+          <a:p xmlns:a="http://schemas.openxmlformats.org/drawingml/2006/main"/>
         </p:txBody>
       </p:sp>
       <p:sp>
@@ -11965,9 +12175,10 @@
             <a:srgbClr val="2A78D6"/>
           </a:solidFill>
         </p:spPr>
-        <p:txBody xmlns:a="http://schemas.openxmlformats.org/drawingml/2006/main">
-          <a:bodyPr/>
-          <a:p/>
+        <p:txBody>
+          <a:bodyPr xmlns:a="http://schemas.openxmlformats.org/drawingml/2006/main"/>
+          <a:lstStyle xmlns:a="http://schemas.openxmlformats.org/drawingml/2006/main"/>
+          <a:p xmlns:a="http://schemas.openxmlformats.org/drawingml/2006/main"/>
         </p:txBody>
       </p:sp>
       <p:sp>
@@ -11996,9 +12207,10 @@
             <a:srgbClr val="2A78D6"/>
           </a:solidFill>
         </p:spPr>
-        <p:txBody xmlns:a="http://schemas.openxmlformats.org/drawingml/2006/main">
-          <a:bodyPr/>
-          <a:p/>
+        <p:txBody>
+          <a:bodyPr xmlns:a="http://schemas.openxmlformats.org/drawingml/2006/main"/>
+          <a:lstStyle xmlns:a="http://schemas.openxmlformats.org/drawingml/2006/main"/>
+          <a:p xmlns:a="http://schemas.openxmlformats.org/drawingml/2006/main"/>
         </p:txBody>
       </p:sp>
       <p:sp>
@@ -12027,9 +12239,10 @@
             <a:srgbClr val="2A78D6"/>
           </a:solidFill>
         </p:spPr>
-        <p:txBody xmlns:a="http://schemas.openxmlformats.org/drawingml/2006/main">
-          <a:bodyPr/>
-          <a:p/>
+        <p:txBody>
+          <a:bodyPr xmlns:a="http://schemas.openxmlformats.org/drawingml/2006/main"/>
+          <a:lstStyle xmlns:a="http://schemas.openxmlformats.org/drawingml/2006/main"/>
+          <a:p xmlns:a="http://schemas.openxmlformats.org/drawingml/2006/main"/>
         </p:txBody>
       </p:sp>
       <p:sp>
@@ -12058,9 +12271,10 @@
             <a:srgbClr val="FAB219"/>
           </a:solidFill>
         </p:spPr>
-        <p:txBody xmlns:a="http://schemas.openxmlformats.org/drawingml/2006/main">
-          <a:bodyPr/>
-          <a:p/>
+        <p:txBody>
+          <a:bodyPr xmlns:a="http://schemas.openxmlformats.org/drawingml/2006/main"/>
+          <a:lstStyle xmlns:a="http://schemas.openxmlformats.org/drawingml/2006/main"/>
+          <a:p xmlns:a="http://schemas.openxmlformats.org/drawingml/2006/main"/>
         </p:txBody>
       </p:sp>
       <p:sp>
@@ -12089,9 +12303,10 @@
             <a:srgbClr val="FAB219"/>
           </a:solidFill>
         </p:spPr>
-        <p:txBody xmlns:a="http://schemas.openxmlformats.org/drawingml/2006/main">
-          <a:bodyPr/>
-          <a:p/>
+        <p:txBody>
+          <a:bodyPr xmlns:a="http://schemas.openxmlformats.org/drawingml/2006/main"/>
+          <a:lstStyle xmlns:a="http://schemas.openxmlformats.org/drawingml/2006/main"/>
+          <a:p xmlns:a="http://schemas.openxmlformats.org/drawingml/2006/main"/>
         </p:txBody>
       </p:sp>
       <p:sp>
@@ -12120,9 +12335,10 @@
             <a:srgbClr val="FAB219"/>
           </a:solidFill>
         </p:spPr>
-        <p:txBody xmlns:a="http://schemas.openxmlformats.org/drawingml/2006/main">
-          <a:bodyPr/>
-          <a:p/>
+        <p:txBody>
+          <a:bodyPr xmlns:a="http://schemas.openxmlformats.org/drawingml/2006/main"/>
+          <a:lstStyle xmlns:a="http://schemas.openxmlformats.org/drawingml/2006/main"/>
+          <a:p xmlns:a="http://schemas.openxmlformats.org/drawingml/2006/main"/>
         </p:txBody>
       </p:sp>
       <p:sp>
@@ -12151,9 +12367,10 @@
             <a:srgbClr val="FAB219"/>
           </a:solidFill>
         </p:spPr>
-        <p:txBody xmlns:a="http://schemas.openxmlformats.org/drawingml/2006/main">
-          <a:bodyPr/>
-          <a:p/>
+        <p:txBody>
+          <a:bodyPr xmlns:a="http://schemas.openxmlformats.org/drawingml/2006/main"/>
+          <a:lstStyle xmlns:a="http://schemas.openxmlformats.org/drawingml/2006/main"/>
+          <a:p xmlns:a="http://schemas.openxmlformats.org/drawingml/2006/main"/>
         </p:txBody>
       </p:sp>
       <p:sp>
@@ -12182,9 +12399,10 @@
             <a:srgbClr val="D03B3B"/>
           </a:solidFill>
         </p:spPr>
-        <p:txBody xmlns:a="http://schemas.openxmlformats.org/drawingml/2006/main">
-          <a:bodyPr/>
-          <a:p/>
+        <p:txBody>
+          <a:bodyPr xmlns:a="http://schemas.openxmlformats.org/drawingml/2006/main"/>
+          <a:lstStyle xmlns:a="http://schemas.openxmlformats.org/drawingml/2006/main"/>
+          <a:p xmlns:a="http://schemas.openxmlformats.org/drawingml/2006/main"/>
         </p:txBody>
       </p:sp>
       <p:sp>
@@ -12213,9 +12431,10 @@
             <a:srgbClr val="D03B3B"/>
           </a:solidFill>
         </p:spPr>
-        <p:txBody xmlns:a="http://schemas.openxmlformats.org/drawingml/2006/main">
-          <a:bodyPr/>
-          <a:p/>
+        <p:txBody>
+          <a:bodyPr xmlns:a="http://schemas.openxmlformats.org/drawingml/2006/main"/>
+          <a:lstStyle xmlns:a="http://schemas.openxmlformats.org/drawingml/2006/main"/>
+          <a:p xmlns:a="http://schemas.openxmlformats.org/drawingml/2006/main"/>
         </p:txBody>
       </p:sp>
       <p:sp>
@@ -12244,9 +12463,10 @@
             <a:srgbClr val="D03B3B"/>
           </a:solidFill>
         </p:spPr>
-        <p:txBody xmlns:a="http://schemas.openxmlformats.org/drawingml/2006/main">
-          <a:bodyPr/>
-          <a:p/>
+        <p:txBody>
+          <a:bodyPr xmlns:a="http://schemas.openxmlformats.org/drawingml/2006/main"/>
+          <a:lstStyle xmlns:a="http://schemas.openxmlformats.org/drawingml/2006/main"/>
+          <a:p xmlns:a="http://schemas.openxmlformats.org/drawingml/2006/main"/>
         </p:txBody>
       </p:sp>
       <p:sp>
@@ -12275,9 +12495,10 @@
             <a:srgbClr val="D03B3B"/>
           </a:solidFill>
         </p:spPr>
-        <p:txBody xmlns:a="http://schemas.openxmlformats.org/drawingml/2006/main">
-          <a:bodyPr/>
-          <a:p/>
+        <p:txBody>
+          <a:bodyPr xmlns:a="http://schemas.openxmlformats.org/drawingml/2006/main"/>
+          <a:lstStyle xmlns:a="http://schemas.openxmlformats.org/drawingml/2006/main"/>
+          <a:p xmlns:a="http://schemas.openxmlformats.org/drawingml/2006/main"/>
         </p:txBody>
       </p:sp>
       <p:sp>
@@ -12405,9 +12626,10 @@
             <a:srgbClr val="24343F"/>
           </a:solidFill>
         </p:spPr>
-        <p:txBody xmlns:a="http://schemas.openxmlformats.org/drawingml/2006/main">
-          <a:bodyPr/>
-          <a:p/>
+        <p:txBody>
+          <a:bodyPr xmlns:a="http://schemas.openxmlformats.org/drawingml/2006/main"/>
+          <a:lstStyle xmlns:a="http://schemas.openxmlformats.org/drawingml/2006/main"/>
+          <a:p xmlns:a="http://schemas.openxmlformats.org/drawingml/2006/main"/>
         </p:txBody>
       </p:sp>
       <p:sp>
@@ -12436,9 +12658,10 @@
             <a:srgbClr val="2A78D6"/>
           </a:solidFill>
         </p:spPr>
-        <p:txBody xmlns:a="http://schemas.openxmlformats.org/drawingml/2006/main">
-          <a:bodyPr/>
-          <a:p/>
+        <p:txBody>
+          <a:bodyPr xmlns:a="http://schemas.openxmlformats.org/drawingml/2006/main"/>
+          <a:lstStyle xmlns:a="http://schemas.openxmlformats.org/drawingml/2006/main"/>
+          <a:p xmlns:a="http://schemas.openxmlformats.org/drawingml/2006/main"/>
         </p:txBody>
       </p:sp>
       <p:sp>
@@ -12481,7 +12704,7 @@
                 <a:ea typeface="Calibri"/>
                 <a:cs typeface="Calibri"/>
               </a:rPr>
-              <a:t>Demo, not production. Agreement with consumer-selected CFPB labels is 60.5% — not deployment accuracy. The demo stops for human review; Phase 1 runs in shadow, with no action on suggestions.</a:t>
+              <a:t>Demo, not production. Agreement with consumer-selected CFPB labels is 60.5% — not deployment accuracy. The demo never routes autonomously; Phase 1 runs in shadow, with no action on suggestions.</a:t>
             </a:r>
             <a:endParaRPr sz="1250"/>
           </a:p>
@@ -12588,9 +12811,10 @@
             <a:srgbClr val="24343F"/>
           </a:solidFill>
         </p:spPr>
-        <p:txBody xmlns:a="http://schemas.openxmlformats.org/drawingml/2006/main">
-          <a:bodyPr/>
-          <a:p/>
+        <p:txBody>
+          <a:bodyPr xmlns:a="http://schemas.openxmlformats.org/drawingml/2006/main"/>
+          <a:lstStyle xmlns:a="http://schemas.openxmlformats.org/drawingml/2006/main"/>
+          <a:p xmlns:a="http://schemas.openxmlformats.org/drawingml/2006/main"/>
         </p:txBody>
       </p:sp>
       <p:pic>
@@ -12602,7 +12826,7 @@
           <p:nvPr/>
         </p:nvPicPr>
         <p:blipFill>
-          <a:blip xmlns:r="http://schemas.openxmlformats.org/officeDocument/2006/relationships" xmlns:a="http://schemas.openxmlformats.org/drawingml/2006/main" r:embed="R1cec721bd7c54551"/>
+          <a:blip xmlns:r="http://schemas.openxmlformats.org/officeDocument/2006/relationships" xmlns:a="http://schemas.openxmlformats.org/drawingml/2006/main" r:embed="R31612a76c9134ad6"/>
           <a:stretch xmlns:a="http://schemas.openxmlformats.org/drawingml/2006/main">
             <a:fillRect l="0" t="0" r="0" b="0"/>
           </a:stretch>
@@ -12693,9 +12917,10 @@
             <a:prstDash val="solid"/>
           </a:ln>
         </p:spPr>
-        <p:txBody xmlns:a="http://schemas.openxmlformats.org/drawingml/2006/main">
-          <a:bodyPr/>
-          <a:p/>
+        <p:txBody>
+          <a:bodyPr xmlns:a="http://schemas.openxmlformats.org/drawingml/2006/main"/>
+          <a:lstStyle xmlns:a="http://schemas.openxmlformats.org/drawingml/2006/main"/>
+          <a:p xmlns:a="http://schemas.openxmlformats.org/drawingml/2006/main"/>
         </p:txBody>
       </p:sp>
       <p:sp>
@@ -12740,7 +12965,7 @@
                   <a:srgbClr val="6B7C88"/>
                 </a:solidFill>
               </a:rPr>
-              <a:t>Sources: FCA complaint benchmark; Financial Ombudsman Service case fee; project cost model.</a:t>
+              <a:t>Sources: FCA and FOS benchmarks; OpenAI API pricing; project cost model.</a:t>
             </a:r>
             <a:endParaRPr sz="850"/>
           </a:p>
@@ -12818,9 +13043,10 @@
             <a:srgbClr val="24343F"/>
           </a:solidFill>
         </p:spPr>
-        <p:txBody xmlns:a="http://schemas.openxmlformats.org/drawingml/2006/main">
-          <a:bodyPr/>
-          <a:p/>
+        <p:txBody>
+          <a:bodyPr xmlns:a="http://schemas.openxmlformats.org/drawingml/2006/main"/>
+          <a:lstStyle xmlns:a="http://schemas.openxmlformats.org/drawingml/2006/main"/>
+          <a:p xmlns:a="http://schemas.openxmlformats.org/drawingml/2006/main"/>
         </p:txBody>
       </p:sp>
       <p:sp>
@@ -12849,9 +13075,10 @@
             <a:srgbClr val="445A69"/>
           </a:solidFill>
         </p:spPr>
-        <p:txBody xmlns:a="http://schemas.openxmlformats.org/drawingml/2006/main">
-          <a:bodyPr/>
-          <a:p/>
+        <p:txBody>
+          <a:bodyPr xmlns:a="http://schemas.openxmlformats.org/drawingml/2006/main"/>
+          <a:lstStyle xmlns:a="http://schemas.openxmlformats.org/drawingml/2006/main"/>
+          <a:p xmlns:a="http://schemas.openxmlformats.org/drawingml/2006/main"/>
         </p:txBody>
       </p:sp>
       <p:sp>
@@ -12880,9 +13107,10 @@
             <a:srgbClr val="2A78D6"/>
           </a:solidFill>
         </p:spPr>
-        <p:txBody xmlns:a="http://schemas.openxmlformats.org/drawingml/2006/main">
-          <a:bodyPr/>
-          <a:p/>
+        <p:txBody>
+          <a:bodyPr xmlns:a="http://schemas.openxmlformats.org/drawingml/2006/main"/>
+          <a:lstStyle xmlns:a="http://schemas.openxmlformats.org/drawingml/2006/main"/>
+          <a:p xmlns:a="http://schemas.openxmlformats.org/drawingml/2006/main"/>
         </p:txBody>
       </p:sp>
       <p:sp>
@@ -13099,9 +13327,10 @@
             <a:prstDash val="solid"/>
           </a:ln>
         </p:spPr>
-        <p:txBody xmlns:a="http://schemas.openxmlformats.org/drawingml/2006/main">
-          <a:bodyPr/>
-          <a:p/>
+        <p:txBody>
+          <a:bodyPr xmlns:a="http://schemas.openxmlformats.org/drawingml/2006/main"/>
+          <a:lstStyle xmlns:a="http://schemas.openxmlformats.org/drawingml/2006/main"/>
+          <a:p xmlns:a="http://schemas.openxmlformats.org/drawingml/2006/main"/>
         </p:txBody>
       </p:sp>
       <p:sp>
@@ -13136,9 +13365,10 @@
             <a:prstDash val="solid"/>
           </a:ln>
         </p:spPr>
-        <p:txBody xmlns:a="http://schemas.openxmlformats.org/drawingml/2006/main">
-          <a:bodyPr/>
-          <a:p/>
+        <p:txBody>
+          <a:bodyPr xmlns:a="http://schemas.openxmlformats.org/drawingml/2006/main"/>
+          <a:lstStyle xmlns:a="http://schemas.openxmlformats.org/drawingml/2006/main"/>
+          <a:p xmlns:a="http://schemas.openxmlformats.org/drawingml/2006/main"/>
         </p:txBody>
       </p:sp>
       <p:sp>
@@ -13226,9 +13456,10 @@
             </a:outerShdw>
           </a:effectLst>
         </p:spPr>
-        <p:txBody xmlns:a="http://schemas.openxmlformats.org/drawingml/2006/main">
-          <a:bodyPr/>
-          <a:p/>
+        <p:txBody>
+          <a:bodyPr xmlns:a="http://schemas.openxmlformats.org/drawingml/2006/main"/>
+          <a:lstStyle xmlns:a="http://schemas.openxmlformats.org/drawingml/2006/main"/>
+          <a:p xmlns:a="http://schemas.openxmlformats.org/drawingml/2006/main"/>
         </p:txBody>
       </p:sp>
       <p:sp>
@@ -13355,9 +13586,10 @@
             <a:prstDash val="solid"/>
           </a:ln>
         </p:spPr>
-        <p:txBody xmlns:a="http://schemas.openxmlformats.org/drawingml/2006/main">
-          <a:bodyPr/>
-          <a:p/>
+        <p:txBody>
+          <a:bodyPr xmlns:a="http://schemas.openxmlformats.org/drawingml/2006/main"/>
+          <a:lstStyle xmlns:a="http://schemas.openxmlformats.org/drawingml/2006/main"/>
+          <a:p xmlns:a="http://schemas.openxmlformats.org/drawingml/2006/main"/>
         </p:txBody>
       </p:sp>
       <p:sp>
@@ -13445,9 +13677,10 @@
             </a:outerShdw>
           </a:effectLst>
         </p:spPr>
-        <p:txBody xmlns:a="http://schemas.openxmlformats.org/drawingml/2006/main">
-          <a:bodyPr/>
-          <a:p/>
+        <p:txBody>
+          <a:bodyPr xmlns:a="http://schemas.openxmlformats.org/drawingml/2006/main"/>
+          <a:lstStyle xmlns:a="http://schemas.openxmlformats.org/drawingml/2006/main"/>
+          <a:p xmlns:a="http://schemas.openxmlformats.org/drawingml/2006/main"/>
         </p:txBody>
       </p:sp>
       <p:sp>
@@ -13574,9 +13807,10 @@
             <a:prstDash val="solid"/>
           </a:ln>
         </p:spPr>
-        <p:txBody xmlns:a="http://schemas.openxmlformats.org/drawingml/2006/main">
-          <a:bodyPr/>
-          <a:p/>
+        <p:txBody>
+          <a:bodyPr xmlns:a="http://schemas.openxmlformats.org/drawingml/2006/main"/>
+          <a:lstStyle xmlns:a="http://schemas.openxmlformats.org/drawingml/2006/main"/>
+          <a:p xmlns:a="http://schemas.openxmlformats.org/drawingml/2006/main"/>
         </p:txBody>
       </p:sp>
       <p:sp>
@@ -13664,9 +13898,10 @@
             </a:outerShdw>
           </a:effectLst>
         </p:spPr>
-        <p:txBody xmlns:a="http://schemas.openxmlformats.org/drawingml/2006/main">
-          <a:bodyPr/>
-          <a:p/>
+        <p:txBody>
+          <a:bodyPr xmlns:a="http://schemas.openxmlformats.org/drawingml/2006/main"/>
+          <a:lstStyle xmlns:a="http://schemas.openxmlformats.org/drawingml/2006/main"/>
+          <a:p xmlns:a="http://schemas.openxmlformats.org/drawingml/2006/main"/>
         </p:txBody>
       </p:sp>
       <p:sp>
@@ -13787,9 +14022,10 @@
             <a:srgbClr val="EFF5F9"/>
           </a:solidFill>
         </p:spPr>
-        <p:txBody xmlns:a="http://schemas.openxmlformats.org/drawingml/2006/main">
-          <a:bodyPr/>
-          <a:p/>
+        <p:txBody>
+          <a:bodyPr xmlns:a="http://schemas.openxmlformats.org/drawingml/2006/main"/>
+          <a:lstStyle xmlns:a="http://schemas.openxmlformats.org/drawingml/2006/main"/>
+          <a:p xmlns:a="http://schemas.openxmlformats.org/drawingml/2006/main"/>
         </p:txBody>
       </p:sp>
       <p:sp>
@@ -13818,9 +14054,10 @@
             <a:srgbClr val="2A78D6"/>
           </a:solidFill>
         </p:spPr>
-        <p:txBody xmlns:a="http://schemas.openxmlformats.org/drawingml/2006/main">
-          <a:bodyPr/>
-          <a:p/>
+        <p:txBody>
+          <a:bodyPr xmlns:a="http://schemas.openxmlformats.org/drawingml/2006/main"/>
+          <a:lstStyle xmlns:a="http://schemas.openxmlformats.org/drawingml/2006/main"/>
+          <a:p xmlns:a="http://schemas.openxmlformats.org/drawingml/2006/main"/>
         </p:txBody>
       </p:sp>
       <p:sp>
@@ -13992,9 +14229,10 @@
             <a:srgbClr val="24343F"/>
           </a:solidFill>
         </p:spPr>
-        <p:txBody xmlns:a="http://schemas.openxmlformats.org/drawingml/2006/main">
-          <a:bodyPr/>
-          <a:p/>
+        <p:txBody>
+          <a:bodyPr xmlns:a="http://schemas.openxmlformats.org/drawingml/2006/main"/>
+          <a:lstStyle xmlns:a="http://schemas.openxmlformats.org/drawingml/2006/main"/>
+          <a:p xmlns:a="http://schemas.openxmlformats.org/drawingml/2006/main"/>
         </p:txBody>
       </p:sp>
       <p:pic>
@@ -14006,7 +14244,7 @@
           <p:nvPr/>
         </p:nvPicPr>
         <p:blipFill>
-          <a:blip xmlns:r="http://schemas.openxmlformats.org/officeDocument/2006/relationships" xmlns:a="http://schemas.openxmlformats.org/drawingml/2006/main" r:embed="Rf6c7ee433bda429f"/>
+          <a:blip xmlns:r="http://schemas.openxmlformats.org/officeDocument/2006/relationships" xmlns:a="http://schemas.openxmlformats.org/drawingml/2006/main" r:embed="R153459dcced24c1a"/>
           <a:stretch xmlns:a="http://schemas.openxmlformats.org/drawingml/2006/main">
             <a:fillRect l="0" t="0" r="0" b="0"/>
           </a:stretch>
@@ -14220,9 +14458,10 @@
             <a:srgbClr val="24343F"/>
           </a:solidFill>
         </p:spPr>
-        <p:txBody xmlns:a="http://schemas.openxmlformats.org/drawingml/2006/main">
-          <a:bodyPr/>
-          <a:p/>
+        <p:txBody>
+          <a:bodyPr xmlns:a="http://schemas.openxmlformats.org/drawingml/2006/main"/>
+          <a:lstStyle xmlns:a="http://schemas.openxmlformats.org/drawingml/2006/main"/>
+          <a:p xmlns:a="http://schemas.openxmlformats.org/drawingml/2006/main"/>
         </p:txBody>
       </p:sp>
       <p:pic>
@@ -14234,7 +14473,7 @@
           <p:nvPr/>
         </p:nvPicPr>
         <p:blipFill>
-          <a:blip xmlns:r="http://schemas.openxmlformats.org/officeDocument/2006/relationships" xmlns:a="http://schemas.openxmlformats.org/drawingml/2006/main" r:embed="R380e739bb4934b50"/>
+          <a:blip xmlns:r="http://schemas.openxmlformats.org/officeDocument/2006/relationships" xmlns:a="http://schemas.openxmlformats.org/drawingml/2006/main" r:embed="R38364d0519e84076"/>
           <a:stretch xmlns:a="http://schemas.openxmlformats.org/drawingml/2006/main">
             <a:fillRect l="0" t="0" r="0" b="0"/>
           </a:stretch>
@@ -14321,9 +14560,10 @@
             <a:srgbClr val="EFF5F9"/>
           </a:solidFill>
         </p:spPr>
-        <p:txBody xmlns:a="http://schemas.openxmlformats.org/drawingml/2006/main">
-          <a:bodyPr/>
-          <a:p/>
+        <p:txBody>
+          <a:bodyPr xmlns:a="http://schemas.openxmlformats.org/drawingml/2006/main"/>
+          <a:lstStyle xmlns:a="http://schemas.openxmlformats.org/drawingml/2006/main"/>
+          <a:p xmlns:a="http://schemas.openxmlformats.org/drawingml/2006/main"/>
         </p:txBody>
       </p:sp>
       <p:sp>
@@ -14352,9 +14592,10 @@
             <a:srgbClr val="2A78D6"/>
           </a:solidFill>
         </p:spPr>
-        <p:txBody xmlns:a="http://schemas.openxmlformats.org/drawingml/2006/main">
-          <a:bodyPr/>
-          <a:p/>
+        <p:txBody>
+          <a:bodyPr xmlns:a="http://schemas.openxmlformats.org/drawingml/2006/main"/>
+          <a:lstStyle xmlns:a="http://schemas.openxmlformats.org/drawingml/2006/main"/>
+          <a:p xmlns:a="http://schemas.openxmlformats.org/drawingml/2006/main"/>
         </p:txBody>
       </p:sp>
       <p:sp>
@@ -14444,9 +14685,10 @@
             <a:prstDash val="solid"/>
           </a:ln>
         </p:spPr>
-        <p:txBody xmlns:a="http://schemas.openxmlformats.org/drawingml/2006/main">
-          <a:bodyPr/>
-          <a:p/>
+        <p:txBody>
+          <a:bodyPr xmlns:a="http://schemas.openxmlformats.org/drawingml/2006/main"/>
+          <a:lstStyle xmlns:a="http://schemas.openxmlformats.org/drawingml/2006/main"/>
+          <a:p xmlns:a="http://schemas.openxmlformats.org/drawingml/2006/main"/>
         </p:txBody>
       </p:sp>
       <p:sp>
@@ -14569,9 +14811,10 @@
             </a:outerShdw>
           </a:effectLst>
         </p:spPr>
-        <p:txBody xmlns:a="http://schemas.openxmlformats.org/drawingml/2006/main">
-          <a:bodyPr/>
-          <a:p/>
+        <p:txBody>
+          <a:bodyPr xmlns:a="http://schemas.openxmlformats.org/drawingml/2006/main"/>
+          <a:lstStyle xmlns:a="http://schemas.openxmlformats.org/drawingml/2006/main"/>
+          <a:p xmlns:a="http://schemas.openxmlformats.org/drawingml/2006/main"/>
         </p:txBody>
       </p:sp>
       <p:sp>
@@ -14600,9 +14843,10 @@
             <a:srgbClr val="24343F"/>
           </a:solidFill>
         </p:spPr>
-        <p:txBody xmlns:a="http://schemas.openxmlformats.org/drawingml/2006/main">
-          <a:bodyPr/>
-          <a:p/>
+        <p:txBody>
+          <a:bodyPr xmlns:a="http://schemas.openxmlformats.org/drawingml/2006/main"/>
+          <a:lstStyle xmlns:a="http://schemas.openxmlformats.org/drawingml/2006/main"/>
+          <a:p xmlns:a="http://schemas.openxmlformats.org/drawingml/2006/main"/>
         </p:txBody>
       </p:sp>
       <p:sp>
@@ -14782,9 +15026,10 @@
             </a:outerShdw>
           </a:effectLst>
         </p:spPr>
-        <p:txBody xmlns:a="http://schemas.openxmlformats.org/drawingml/2006/main">
-          <a:bodyPr/>
-          <a:p/>
+        <p:txBody>
+          <a:bodyPr xmlns:a="http://schemas.openxmlformats.org/drawingml/2006/main"/>
+          <a:lstStyle xmlns:a="http://schemas.openxmlformats.org/drawingml/2006/main"/>
+          <a:p xmlns:a="http://schemas.openxmlformats.org/drawingml/2006/main"/>
         </p:txBody>
       </p:sp>
       <p:sp>
@@ -14813,9 +15058,10 @@
             <a:srgbClr val="445A69"/>
           </a:solidFill>
         </p:spPr>
-        <p:txBody xmlns:a="http://schemas.openxmlformats.org/drawingml/2006/main">
-          <a:bodyPr/>
-          <a:p/>
+        <p:txBody>
+          <a:bodyPr xmlns:a="http://schemas.openxmlformats.org/drawingml/2006/main"/>
+          <a:lstStyle xmlns:a="http://schemas.openxmlformats.org/drawingml/2006/main"/>
+          <a:p xmlns:a="http://schemas.openxmlformats.org/drawingml/2006/main"/>
         </p:txBody>
       </p:sp>
       <p:sp>
@@ -15057,9 +15303,10 @@
             <a:srgbClr val="24343F"/>
           </a:solidFill>
         </p:spPr>
-        <p:txBody xmlns:a="http://schemas.openxmlformats.org/drawingml/2006/main">
-          <a:bodyPr/>
-          <a:p/>
+        <p:txBody>
+          <a:bodyPr xmlns:a="http://schemas.openxmlformats.org/drawingml/2006/main"/>
+          <a:lstStyle xmlns:a="http://schemas.openxmlformats.org/drawingml/2006/main"/>
+          <a:p xmlns:a="http://schemas.openxmlformats.org/drawingml/2006/main"/>
         </p:txBody>
       </p:sp>
       <p:pic>
@@ -15071,7 +15318,7 @@
           <p:nvPr/>
         </p:nvPicPr>
         <p:blipFill>
-          <a:blip xmlns:r="http://schemas.openxmlformats.org/officeDocument/2006/relationships" xmlns:a="http://schemas.openxmlformats.org/drawingml/2006/main" r:embed="R6f2841d48071433e"/>
+          <a:blip xmlns:r="http://schemas.openxmlformats.org/officeDocument/2006/relationships" xmlns:a="http://schemas.openxmlformats.org/drawingml/2006/main" r:embed="Rc0edef589ac64453"/>
           <a:stretch xmlns:a="http://schemas.openxmlformats.org/drawingml/2006/main">
             <a:fillRect l="0" t="0" r="0" b="0"/>
           </a:stretch>
@@ -15158,9 +15405,10 @@
             <a:srgbClr val="EFF5F9"/>
           </a:solidFill>
         </p:spPr>
-        <p:txBody xmlns:a="http://schemas.openxmlformats.org/drawingml/2006/main">
-          <a:bodyPr/>
-          <a:p/>
+        <p:txBody>
+          <a:bodyPr xmlns:a="http://schemas.openxmlformats.org/drawingml/2006/main"/>
+          <a:lstStyle xmlns:a="http://schemas.openxmlformats.org/drawingml/2006/main"/>
+          <a:p xmlns:a="http://schemas.openxmlformats.org/drawingml/2006/main"/>
         </p:txBody>
       </p:sp>
       <p:sp>
@@ -15189,9 +15437,10 @@
             <a:srgbClr val="2A78D6"/>
           </a:solidFill>
         </p:spPr>
-        <p:txBody xmlns:a="http://schemas.openxmlformats.org/drawingml/2006/main">
-          <a:bodyPr/>
-          <a:p/>
+        <p:txBody>
+          <a:bodyPr xmlns:a="http://schemas.openxmlformats.org/drawingml/2006/main"/>
+          <a:lstStyle xmlns:a="http://schemas.openxmlformats.org/drawingml/2006/main"/>
+          <a:p xmlns:a="http://schemas.openxmlformats.org/drawingml/2006/main"/>
         </p:txBody>
       </p:sp>
       <p:sp>
@@ -15270,9 +15519,10 @@
             <a:prstDash val="solid"/>
           </a:ln>
         </p:spPr>
-        <p:txBody xmlns:a="http://schemas.openxmlformats.org/drawingml/2006/main">
-          <a:bodyPr/>
-          <a:p/>
+        <p:txBody>
+          <a:bodyPr xmlns:a="http://schemas.openxmlformats.org/drawingml/2006/main"/>
+          <a:lstStyle xmlns:a="http://schemas.openxmlformats.org/drawingml/2006/main"/>
+          <a:p xmlns:a="http://schemas.openxmlformats.org/drawingml/2006/main"/>
         </p:txBody>
       </p:sp>
       <p:sp>
@@ -15395,9 +15645,10 @@
             <a:srgbClr val="24343F"/>
           </a:solidFill>
         </p:spPr>
-        <p:txBody xmlns:a="http://schemas.openxmlformats.org/drawingml/2006/main">
-          <a:bodyPr/>
-          <a:p/>
+        <p:txBody>
+          <a:bodyPr xmlns:a="http://schemas.openxmlformats.org/drawingml/2006/main"/>
+          <a:lstStyle xmlns:a="http://schemas.openxmlformats.org/drawingml/2006/main"/>
+          <a:p xmlns:a="http://schemas.openxmlformats.org/drawingml/2006/main"/>
         </p:txBody>
       </p:sp>
       <p:sp>
@@ -15474,9 +15725,10 @@
             </a:srgbClr>
           </a:solidFill>
         </p:spPr>
-        <p:txBody xmlns:a="http://schemas.openxmlformats.org/drawingml/2006/main">
-          <a:bodyPr/>
-          <a:p/>
+        <p:txBody>
+          <a:bodyPr xmlns:a="http://schemas.openxmlformats.org/drawingml/2006/main"/>
+          <a:lstStyle xmlns:a="http://schemas.openxmlformats.org/drawingml/2006/main"/>
+          <a:p xmlns:a="http://schemas.openxmlformats.org/drawingml/2006/main"/>
         </p:txBody>
       </p:sp>
       <p:sp>
@@ -15553,9 +15805,10 @@
             </a:srgbClr>
           </a:solidFill>
         </p:spPr>
-        <p:txBody xmlns:a="http://schemas.openxmlformats.org/drawingml/2006/main">
-          <a:bodyPr/>
-          <a:p/>
+        <p:txBody>
+          <a:bodyPr xmlns:a="http://schemas.openxmlformats.org/drawingml/2006/main"/>
+          <a:lstStyle xmlns:a="http://schemas.openxmlformats.org/drawingml/2006/main"/>
+          <a:p xmlns:a="http://schemas.openxmlformats.org/drawingml/2006/main"/>
         </p:txBody>
       </p:sp>
       <p:sp>
@@ -15632,9 +15885,10 @@
             </a:srgbClr>
           </a:solidFill>
         </p:spPr>
-        <p:txBody xmlns:a="http://schemas.openxmlformats.org/drawingml/2006/main">
-          <a:bodyPr/>
-          <a:p/>
+        <p:txBody>
+          <a:bodyPr xmlns:a="http://schemas.openxmlformats.org/drawingml/2006/main"/>
+          <a:lstStyle xmlns:a="http://schemas.openxmlformats.org/drawingml/2006/main"/>
+          <a:p xmlns:a="http://schemas.openxmlformats.org/drawingml/2006/main"/>
         </p:txBody>
       </p:sp>
       <p:sp>
@@ -15711,9 +15965,10 @@
             </a:srgbClr>
           </a:solidFill>
         </p:spPr>
-        <p:txBody xmlns:a="http://schemas.openxmlformats.org/drawingml/2006/main">
-          <a:bodyPr/>
-          <a:p/>
+        <p:txBody>
+          <a:bodyPr xmlns:a="http://schemas.openxmlformats.org/drawingml/2006/main"/>
+          <a:lstStyle xmlns:a="http://schemas.openxmlformats.org/drawingml/2006/main"/>
+          <a:p xmlns:a="http://schemas.openxmlformats.org/drawingml/2006/main"/>
         </p:txBody>
       </p:sp>
       <p:sp>
@@ -15795,9 +16050,10 @@
             </a:outerShdw>
           </a:effectLst>
         </p:spPr>
-        <p:txBody xmlns:a="http://schemas.openxmlformats.org/drawingml/2006/main">
-          <a:bodyPr/>
-          <a:p/>
+        <p:txBody>
+          <a:bodyPr xmlns:a="http://schemas.openxmlformats.org/drawingml/2006/main"/>
+          <a:lstStyle xmlns:a="http://schemas.openxmlformats.org/drawingml/2006/main"/>
+          <a:p xmlns:a="http://schemas.openxmlformats.org/drawingml/2006/main"/>
         </p:txBody>
       </p:sp>
       <p:sp>
@@ -15973,9 +16229,10 @@
             <a:srgbClr val="24343F"/>
           </a:solidFill>
         </p:spPr>
-        <p:txBody xmlns:a="http://schemas.openxmlformats.org/drawingml/2006/main">
-          <a:bodyPr/>
-          <a:p/>
+        <p:txBody>
+          <a:bodyPr xmlns:a="http://schemas.openxmlformats.org/drawingml/2006/main"/>
+          <a:lstStyle xmlns:a="http://schemas.openxmlformats.org/drawingml/2006/main"/>
+          <a:p xmlns:a="http://schemas.openxmlformats.org/drawingml/2006/main"/>
         </p:txBody>
       </p:sp>
       <p:pic>
@@ -15987,7 +16244,7 @@
           <p:nvPr/>
         </p:nvPicPr>
         <p:blipFill>
-          <a:blip xmlns:r="http://schemas.openxmlformats.org/officeDocument/2006/relationships" xmlns:a="http://schemas.openxmlformats.org/drawingml/2006/main" r:embed="R13c84005b60948cb"/>
+          <a:blip xmlns:r="http://schemas.openxmlformats.org/officeDocument/2006/relationships" xmlns:a="http://schemas.openxmlformats.org/drawingml/2006/main" r:embed="Ra7c4747d959f484c"/>
           <a:stretch xmlns:a="http://schemas.openxmlformats.org/drawingml/2006/main">
             <a:fillRect l="0" t="0" r="0" b="0"/>
           </a:stretch>
@@ -16074,9 +16331,10 @@
             <a:srgbClr val="EFF5F9"/>
           </a:solidFill>
         </p:spPr>
-        <p:txBody xmlns:a="http://schemas.openxmlformats.org/drawingml/2006/main">
-          <a:bodyPr/>
-          <a:p/>
+        <p:txBody>
+          <a:bodyPr xmlns:a="http://schemas.openxmlformats.org/drawingml/2006/main"/>
+          <a:lstStyle xmlns:a="http://schemas.openxmlformats.org/drawingml/2006/main"/>
+          <a:p xmlns:a="http://schemas.openxmlformats.org/drawingml/2006/main"/>
         </p:txBody>
       </p:sp>
       <p:sp>
@@ -16105,9 +16363,10 @@
             <a:srgbClr val="2A78D6"/>
           </a:solidFill>
         </p:spPr>
-        <p:txBody xmlns:a="http://schemas.openxmlformats.org/drawingml/2006/main">
-          <a:bodyPr/>
-          <a:p/>
+        <p:txBody>
+          <a:bodyPr xmlns:a="http://schemas.openxmlformats.org/drawingml/2006/main"/>
+          <a:lstStyle xmlns:a="http://schemas.openxmlformats.org/drawingml/2006/main"/>
+          <a:p xmlns:a="http://schemas.openxmlformats.org/drawingml/2006/main"/>
         </p:txBody>
       </p:sp>
       <p:sp>
@@ -16186,9 +16445,10 @@
             <a:prstDash val="solid"/>
           </a:ln>
         </p:spPr>
-        <p:txBody xmlns:a="http://schemas.openxmlformats.org/drawingml/2006/main">
-          <a:bodyPr/>
-          <a:p/>
+        <p:txBody>
+          <a:bodyPr xmlns:a="http://schemas.openxmlformats.org/drawingml/2006/main"/>
+          <a:lstStyle xmlns:a="http://schemas.openxmlformats.org/drawingml/2006/main"/>
+          <a:p xmlns:a="http://schemas.openxmlformats.org/drawingml/2006/main"/>
         </p:txBody>
       </p:sp>
       <p:sp>
@@ -17325,9 +17585,10 @@
             <a:srgbClr val="EFF5F9"/>
           </a:solidFill>
         </p:spPr>
-        <p:txBody xmlns:a="http://schemas.openxmlformats.org/drawingml/2006/main">
-          <a:bodyPr/>
-          <a:p/>
+        <p:txBody>
+          <a:bodyPr xmlns:a="http://schemas.openxmlformats.org/drawingml/2006/main"/>
+          <a:lstStyle xmlns:a="http://schemas.openxmlformats.org/drawingml/2006/main"/>
+          <a:p xmlns:a="http://schemas.openxmlformats.org/drawingml/2006/main"/>
         </p:txBody>
       </p:sp>
       <p:sp>
@@ -17356,9 +17617,10 @@
             <a:srgbClr val="2A78D6"/>
           </a:solidFill>
         </p:spPr>
-        <p:txBody xmlns:a="http://schemas.openxmlformats.org/drawingml/2006/main">
-          <a:bodyPr/>
-          <a:p/>
+        <p:txBody>
+          <a:bodyPr xmlns:a="http://schemas.openxmlformats.org/drawingml/2006/main"/>
+          <a:lstStyle xmlns:a="http://schemas.openxmlformats.org/drawingml/2006/main"/>
+          <a:p xmlns:a="http://schemas.openxmlformats.org/drawingml/2006/main"/>
         </p:txBody>
       </p:sp>
       <p:sp>

</xml_diff>

<commit_message>
Give the appendix divider the appendix icon
Slides 6 and 7 shared the handshake icon. The handshake belongs to slide 6, which
carries the ask; slide 7 is the divider that opens the appendix, so it should wear
the same folder icon as the appendix slides it introduces - which it now does.

Every main-run slide (2 to 6) now has a distinct icon, and every appendix slide
including the divider is visually part of the same section. Nothing shared across
the boundary.

Added as its own image part so slide 6 keeps the handshake. Verified: 15 slides
before and after, zero text blocks changed, no blocks added or removed. PDF
re-rendered.
</commit_message>
<xml_diff>
--- a/presentation/round1_pitch.pptx
+++ b/presentation/round1_pitch.pptx
@@ -16734,30 +16734,6 @@
           <a:p xmlns:a="http://schemas.openxmlformats.org/drawingml/2006/main"/>
         </p:txBody>
       </p:sp>
-      <p:pic>
-        <p:nvPicPr>
-          <p:cNvPr id="10" name="Image 0"/>
-          <p:cNvPicPr>
-            <a:picLocks xmlns:a="http://schemas.openxmlformats.org/drawingml/2006/main" noChangeAspect="1"/>
-          </p:cNvPicPr>
-          <p:nvPr/>
-        </p:nvPicPr>
-        <p:blipFill>
-          <a:blip xmlns:r="http://schemas.openxmlformats.org/officeDocument/2006/relationships" xmlns:a="http://schemas.openxmlformats.org/drawingml/2006/main" r:embed="R148d0ca6a8884e2f"/>
-          <a:stretch xmlns:a="http://schemas.openxmlformats.org/drawingml/2006/main">
-            <a:fillRect l="0" t="0" r="0" b="0"/>
-          </a:stretch>
-        </p:blipFill>
-        <p:spPr>
-          <a:xfrm xmlns:a="http://schemas.openxmlformats.org/drawingml/2006/main">
-            <a:off x="708660" y="800100"/>
-            <a:ext cx="283464" cy="283464"/>
-          </a:xfrm>
-          <a:prstGeom xmlns:a="http://schemas.openxmlformats.org/drawingml/2006/main" prst="rect">
-            <a:avLst/>
-          </a:prstGeom>
-        </p:spPr>
-      </p:pic>
       <p:sp>
         <p:nvSpPr>
           <p:cNvPr id="5" name="Text 2">
@@ -16856,6 +16832,30 @@
           </a:p>
         </p:txBody>
       </p:sp>
+      <p:pic xmlns:a="http://schemas.openxmlformats.org/drawingml/2006/main" xmlns:r="http://schemas.openxmlformats.org/officeDocument/2006/relationships">
+        <p:nvPicPr>
+          <p:cNvPr id="11" name="Picture 10" descr="image.png"/>
+          <p:cNvPicPr>
+            <a:picLocks noChangeAspect="1"/>
+          </p:cNvPicPr>
+          <p:nvPr/>
+        </p:nvPicPr>
+        <p:blipFill>
+          <a:blip r:embed="rId4"/>
+          <a:stretch>
+            <a:fillRect/>
+          </a:stretch>
+        </p:blipFill>
+        <p:spPr>
+          <a:xfrm>
+            <a:off x="708660" y="800100"/>
+            <a:ext cx="283464" cy="283464"/>
+          </a:xfrm>
+          <a:prstGeom prst="rect">
+            <a:avLst/>
+          </a:prstGeom>
+        </p:spPr>
+      </p:pic>
     </p:spTree>
     <p:extLst>
       <p:ext uri="{BB962C8B-B14F-4D97-AF65-F5344CB8AC3E}">

</xml_diff>